<commit_message>
CS -ss collected and Presentation updated
</commit_message>
<xml_diff>
--- a/Thesis-Defense/defense/200112_Defense_Presentation.pptx
+++ b/Thesis-Defense/defense/200112_Defense_Presentation.pptx
@@ -25188,7 +25188,7 @@
         <p:spPr>
           <a:xfrm>
             <a:off x="320040" y="2450592"/>
-            <a:ext cx="3931920" cy="2450592"/>
+            <a:ext cx="4096096" cy="2450592"/>
           </a:xfrm>
           <a:prstGeom prst="rect">
             <a:avLst/>
@@ -25227,7 +25227,7 @@
         <p:spPr>
           <a:xfrm>
             <a:off x="411480" y="2523744"/>
-            <a:ext cx="3749040" cy="2304288"/>
+            <a:ext cx="3931920" cy="2304288"/>
           </a:xfrm>
           <a:prstGeom prst="rect">
             <a:avLst/>
@@ -25242,7 +25242,7 @@
         </p:nvSpPr>
         <p:spPr>
           <a:xfrm>
-            <a:off x="320040" y="4846320"/>
+            <a:off x="320040" y="4898275"/>
             <a:ext cx="3931920" cy="228600"/>
           </a:xfrm>
           <a:prstGeom prst="rect">
@@ -25284,8 +25284,8 @@
         </p:nvSpPr>
         <p:spPr>
           <a:xfrm>
-            <a:off x="4835929" y="2456272"/>
-            <a:ext cx="3931920" cy="2450592"/>
+            <a:off x="4571584" y="2456272"/>
+            <a:ext cx="4196265" cy="2450592"/>
           </a:xfrm>
           <a:prstGeom prst="rect">
             <a:avLst/>
@@ -25323,35 +25323,35 @@
           <p:nvPr>
             <p:extLst>
               <p:ext uri="{D42A27DB-BD31-4B8C-83A1-F6EECF244321}">
-                <p14:modId xmlns:p14="http://schemas.microsoft.com/office/powerpoint/2010/main" val="3203760791"/>
+                <p14:modId xmlns:p14="http://schemas.microsoft.com/office/powerpoint/2010/main" val="1002821963"/>
               </p:ext>
             </p:extLst>
           </p:nvPr>
         </p:nvGraphicFramePr>
         <p:xfrm>
-          <a:off x="4998028" y="2615185"/>
-          <a:ext cx="3551613" cy="2252050"/>
+          <a:off x="4663024" y="2563230"/>
+          <a:ext cx="3982212" cy="2371580"/>
         </p:xfrm>
         <a:graphic>
           <a:graphicData uri="http://schemas.openxmlformats.org/drawingml/2006/table">
             <a:tbl>
               <a:tblPr/>
               <a:tblGrid>
-                <a:gridCol w="1183871">
+                <a:gridCol w="1031194">
                   <a:extLst>
                     <a:ext uri="{9D8B030D-6E8A-4147-A177-3AD203B41FA5}">
                       <a16:colId xmlns:a16="http://schemas.microsoft.com/office/drawing/2014/main" val="2678028350"/>
                     </a:ext>
                   </a:extLst>
                 </a:gridCol>
-                <a:gridCol w="1183871">
+                <a:gridCol w="1392382">
                   <a:extLst>
                     <a:ext uri="{9D8B030D-6E8A-4147-A177-3AD203B41FA5}">
                       <a16:colId xmlns:a16="http://schemas.microsoft.com/office/drawing/2014/main" val="366697314"/>
                     </a:ext>
                   </a:extLst>
                 </a:gridCol>
-                <a:gridCol w="1183871">
+                <a:gridCol w="1558636">
                   <a:extLst>
                     <a:ext uri="{9D8B030D-6E8A-4147-A177-3AD203B41FA5}">
                       <a16:colId xmlns:a16="http://schemas.microsoft.com/office/drawing/2014/main" val="2338976362"/>
@@ -25366,7 +25366,7 @@
                     <a:lstStyle/>
                     <a:p>
                       <a:r>
-                        <a:rPr lang="en-US" sz="800" b="1"/>
+                        <a:rPr lang="en-US" sz="1000" b="1" dirty="0"/>
                         <a:t>Direction</a:t>
                       </a:r>
                     </a:p>
@@ -25393,7 +25393,7 @@
                     <a:lstStyle/>
                     <a:p>
                       <a:r>
-                        <a:rPr lang="en-US" sz="800" b="1"/>
+                        <a:rPr lang="en-US" sz="1000" b="1" dirty="0"/>
                         <a:t>Route ID</a:t>
                       </a:r>
                     </a:p>
@@ -25420,7 +25420,7 @@
                     <a:lstStyle/>
                     <a:p>
                       <a:r>
-                        <a:rPr lang="en-US" sz="800" b="1" dirty="0"/>
+                        <a:rPr lang="en-US" sz="1000" b="1" dirty="0"/>
                         <a:t>Edge Sequence</a:t>
                       </a:r>
                     </a:p>
@@ -25454,7 +25454,7 @@
                     <a:lstStyle/>
                     <a:p>
                       <a:r>
-                        <a:rPr lang="en-US" sz="700"/>
+                        <a:rPr lang="en-US" sz="900" dirty="0"/>
                         <a:t>Forward</a:t>
                       </a:r>
                     </a:p>
@@ -25481,7 +25481,7 @@
                     <a:lstStyle/>
                     <a:p>
                       <a:r>
-                        <a:rPr lang="en-US" sz="700"/>
+                        <a:rPr lang="en-US" sz="900"/>
                         <a:t>route1_forward</a:t>
                       </a:r>
                     </a:p>
@@ -25508,7 +25508,7 @@
                     <a:lstStyle/>
                     <a:p>
                       <a:r>
-                        <a:rPr lang="en-US" sz="700"/>
+                        <a:rPr lang="en-US" sz="900"/>
                         <a:t>E0 → E1 → E2 → E3</a:t>
                       </a:r>
                     </a:p>
@@ -25542,7 +25542,7 @@
                     <a:lstStyle/>
                     <a:p>
                       <a:r>
-                        <a:rPr lang="en-US" sz="700" dirty="0"/>
+                        <a:rPr lang="en-US" sz="900" dirty="0"/>
                         <a:t>Forward</a:t>
                       </a:r>
                     </a:p>
@@ -25569,7 +25569,7 @@
                     <a:lstStyle/>
                     <a:p>
                       <a:r>
-                        <a:rPr lang="en-US" sz="700"/>
+                        <a:rPr lang="en-US" sz="900"/>
                         <a:t>route2_forward</a:t>
                       </a:r>
                     </a:p>
@@ -25596,7 +25596,7 @@
                     <a:lstStyle/>
                     <a:p>
                       <a:r>
-                        <a:rPr lang="en-US" sz="700"/>
+                        <a:rPr lang="en-US" sz="900"/>
                         <a:t>E0 → E1 → E9 → E8</a:t>
                       </a:r>
                     </a:p>
@@ -25630,7 +25630,7 @@
                     <a:lstStyle/>
                     <a:p>
                       <a:r>
-                        <a:rPr lang="en-US" sz="700" dirty="0"/>
+                        <a:rPr lang="en-US" sz="900" dirty="0"/>
                         <a:t>Forward</a:t>
                       </a:r>
                     </a:p>
@@ -25657,7 +25657,7 @@
                     <a:lstStyle/>
                     <a:p>
                       <a:r>
-                        <a:rPr lang="en-US" sz="700"/>
+                        <a:rPr lang="en-US" sz="900" dirty="0"/>
                         <a:t>route3_forward</a:t>
                       </a:r>
                     </a:p>
@@ -25684,7 +25684,7 @@
                     <a:lstStyle/>
                     <a:p>
                       <a:r>
-                        <a:rPr lang="en-US" sz="700"/>
+                        <a:rPr lang="en-US" sz="900"/>
                         <a:t>E4 → E5 → E6 → E7 → E8</a:t>
                       </a:r>
                     </a:p>
@@ -25718,7 +25718,7 @@
                     <a:lstStyle/>
                     <a:p>
                       <a:r>
-                        <a:rPr lang="en-US" sz="700"/>
+                        <a:rPr lang="en-US" sz="900"/>
                         <a:t>Forward</a:t>
                       </a:r>
                     </a:p>
@@ -25745,7 +25745,7 @@
                     <a:lstStyle/>
                     <a:p>
                       <a:r>
-                        <a:rPr lang="en-US" sz="700" dirty="0"/>
+                        <a:rPr lang="en-US" sz="900" dirty="0"/>
                         <a:t>route4_forward</a:t>
                       </a:r>
                     </a:p>
@@ -25772,7 +25772,7 @@
                     <a:lstStyle/>
                     <a:p>
                       <a:r>
-                        <a:rPr lang="en-US" sz="700"/>
+                        <a:rPr lang="en-US" sz="900" dirty="0"/>
                         <a:t>E0 → E10 → E7 → E8</a:t>
                       </a:r>
                     </a:p>
@@ -25806,7 +25806,7 @@
                     <a:lstStyle/>
                     <a:p>
                       <a:r>
-                        <a:rPr lang="en-US" sz="700"/>
+                        <a:rPr lang="en-US" sz="900"/>
                         <a:t>Reverse</a:t>
                       </a:r>
                     </a:p>
@@ -25833,7 +25833,7 @@
                     <a:lstStyle/>
                     <a:p>
                       <a:r>
-                        <a:rPr lang="en-US" sz="700"/>
+                        <a:rPr lang="en-US" sz="900"/>
                         <a:t>route1_reverse</a:t>
                       </a:r>
                     </a:p>
@@ -25860,7 +25860,7 @@
                     <a:lstStyle/>
                     <a:p>
                       <a:r>
-                        <a:rPr lang="en-US" sz="700" dirty="0"/>
+                        <a:rPr lang="en-US" sz="900" dirty="0"/>
                         <a:t>-E3 → -E2 → -E1 → -E0</a:t>
                       </a:r>
                     </a:p>
@@ -25894,7 +25894,7 @@
                     <a:lstStyle/>
                     <a:p>
                       <a:r>
-                        <a:rPr lang="en-US" sz="700"/>
+                        <a:rPr lang="en-US" sz="900"/>
                         <a:t>Reverse</a:t>
                       </a:r>
                     </a:p>
@@ -25921,7 +25921,7 @@
                     <a:lstStyle/>
                     <a:p>
                       <a:r>
-                        <a:rPr lang="en-US" sz="700"/>
+                        <a:rPr lang="en-US" sz="900"/>
                         <a:t>route2_reverse</a:t>
                       </a:r>
                     </a:p>
@@ -25948,7 +25948,7 @@
                     <a:lstStyle/>
                     <a:p>
                       <a:r>
-                        <a:rPr lang="en-US" sz="700" dirty="0"/>
+                        <a:rPr lang="en-US" sz="900" dirty="0"/>
                         <a:t>-E8 → -E9 → -E1 → -E0</a:t>
                       </a:r>
                     </a:p>
@@ -25982,7 +25982,7 @@
                     <a:lstStyle/>
                     <a:p>
                       <a:r>
-                        <a:rPr lang="en-US" sz="700"/>
+                        <a:rPr lang="en-US" sz="900"/>
                         <a:t>Reverse</a:t>
                       </a:r>
                     </a:p>
@@ -26009,7 +26009,7 @@
                     <a:lstStyle/>
                     <a:p>
                       <a:r>
-                        <a:rPr lang="en-US" sz="700"/>
+                        <a:rPr lang="en-US" sz="900"/>
                         <a:t>route3_reverse</a:t>
                       </a:r>
                     </a:p>
@@ -26036,7 +26036,7 @@
                     <a:lstStyle/>
                     <a:p>
                       <a:r>
-                        <a:rPr lang="en-US" sz="700"/>
+                        <a:rPr lang="en-US" sz="900"/>
                         <a:t>-E8 → -E7 → -E6 → -E5 → -E4</a:t>
                       </a:r>
                     </a:p>
@@ -26070,7 +26070,7 @@
                     <a:lstStyle/>
                     <a:p>
                       <a:r>
-                        <a:rPr lang="en-US" sz="700"/>
+                        <a:rPr lang="en-US" sz="900" dirty="0"/>
                         <a:t>Reverse</a:t>
                       </a:r>
                     </a:p>
@@ -26097,7 +26097,7 @@
                     <a:lstStyle/>
                     <a:p>
                       <a:r>
-                        <a:rPr lang="en-US" sz="700"/>
+                        <a:rPr lang="en-US" sz="900"/>
                         <a:t>route4_reverse</a:t>
                       </a:r>
                     </a:p>
@@ -26124,7 +26124,7 @@
                     <a:lstStyle/>
                     <a:p>
                       <a:r>
-                        <a:rPr lang="en-US" sz="700" dirty="0"/>
+                        <a:rPr lang="en-US" sz="900" dirty="0"/>
                         <a:t>-E8 → -E7 → -E10 → -E0</a:t>
                       </a:r>
                     </a:p>
@@ -26304,8 +26304,8 @@
         </p:nvSpPr>
         <p:spPr>
           <a:xfrm>
-            <a:off x="320040" y="960120"/>
-            <a:ext cx="8503920" cy="36576"/>
+            <a:off x="320039" y="960120"/>
+            <a:ext cx="8680561" cy="45719"/>
           </a:xfrm>
           <a:prstGeom prst="rect">
             <a:avLst/>
@@ -26323,14 +26323,14 @@
       </p:sp>
       <p:sp>
         <p:nvSpPr>
-          <p:cNvPr id="6" name="Shape 4"/>
-          <p:cNvSpPr/>
-          <p:nvPr/>
-        </p:nvSpPr>
-        <p:spPr>
-          <a:xfrm>
-            <a:off x="320040" y="1115568"/>
-            <a:ext cx="1920240" cy="1143000"/>
+          <p:cNvPr id="26" name="Shape 24"/>
+          <p:cNvSpPr/>
+          <p:nvPr/>
+        </p:nvSpPr>
+        <p:spPr>
+          <a:xfrm>
+            <a:off x="320040" y="1426464"/>
+            <a:ext cx="3931920" cy="3474720"/>
           </a:xfrm>
           <a:prstGeom prst="rect">
             <a:avLst/>
@@ -26355,711 +26355,13 @@
       </p:sp>
       <p:sp>
         <p:nvSpPr>
-          <p:cNvPr id="7" name="Shape 5"/>
-          <p:cNvSpPr/>
-          <p:nvPr/>
-        </p:nvSpPr>
-        <p:spPr>
-          <a:xfrm>
-            <a:off x="320040" y="1115568"/>
-            <a:ext cx="1920240" cy="201168"/>
-          </a:xfrm>
-          <a:prstGeom prst="rect">
-            <a:avLst/>
-          </a:prstGeom>
-          <a:solidFill>
-            <a:srgbClr val="0D7377"/>
-          </a:solidFill>
-          <a:ln w="12700">
-            <a:solidFill>
-              <a:srgbClr val="0D7377"/>
-            </a:solidFill>
-            <a:prstDash val="solid"/>
-          </a:ln>
-        </p:spPr>
-      </p:sp>
-      <p:sp>
-        <p:nvSpPr>
-          <p:cNvPr id="8" name="Text 6"/>
-          <p:cNvSpPr/>
-          <p:nvPr/>
-        </p:nvSpPr>
-        <p:spPr>
-          <a:xfrm>
-            <a:off x="365760" y="1371600"/>
-            <a:ext cx="1828800" cy="566928"/>
-          </a:xfrm>
-          <a:prstGeom prst="rect">
-            <a:avLst/>
-          </a:prstGeom>
-          <a:noFill/>
-          <a:ln/>
-        </p:spPr>
-        <p:txBody>
-          <a:bodyPr wrap="square" lIns="0" tIns="0" rIns="0" bIns="0" rtlCol="0" anchor="ctr"/>
-          <a:lstStyle/>
-          <a:p>
-            <a:pPr marL="0" indent="0" algn="ctr">
-              <a:buNone/>
-            </a:pPr>
-            <a:r>
-              <a:rPr lang="en-US" sz="3200" b="1" dirty="0">
-                <a:solidFill>
-                  <a:srgbClr val="1B3A6B"/>
-                </a:solidFill>
-                <a:latin typeface="Calibri" pitchFamily="34" charset="0"/>
-                <a:ea typeface="Calibri" pitchFamily="34" charset="-122"/>
-                <a:cs typeface="Calibri" pitchFamily="34" charset="-120"/>
-              </a:rPr>
-              <a:t>8,654 m</a:t>
-            </a:r>
-            <a:endParaRPr lang="en-US" sz="3200" dirty="0"/>
-          </a:p>
-        </p:txBody>
-      </p:sp>
-      <p:sp>
-        <p:nvSpPr>
-          <p:cNvPr id="9" name="Text 7"/>
-          <p:cNvSpPr/>
-          <p:nvPr/>
-        </p:nvSpPr>
-        <p:spPr>
-          <a:xfrm>
-            <a:off x="365760" y="1920240"/>
-            <a:ext cx="1828800" cy="292608"/>
-          </a:xfrm>
-          <a:prstGeom prst="rect">
-            <a:avLst/>
-          </a:prstGeom>
-          <a:noFill/>
-          <a:ln/>
-        </p:spPr>
-        <p:txBody>
-          <a:bodyPr wrap="square" lIns="0" tIns="0" rIns="0" bIns="0" rtlCol="0" anchor="ctr"/>
-          <a:lstStyle/>
-          <a:p>
-            <a:pPr marL="0" indent="0" algn="ctr">
-              <a:buNone/>
-            </a:pPr>
-            <a:r>
-              <a:rPr lang="en-US" sz="1000" dirty="0">
-                <a:solidFill>
-                  <a:srgbClr val="64748B"/>
-                </a:solidFill>
-                <a:latin typeface="Calibri" pitchFamily="34" charset="0"/>
-                <a:ea typeface="Calibri" pitchFamily="34" charset="-122"/>
-                <a:cs typeface="Calibri" pitchFamily="34" charset="-120"/>
-              </a:rPr>
-              <a:t>Total Road Network</a:t>
-            </a:r>
-            <a:endParaRPr lang="en-US" sz="1000" dirty="0"/>
-          </a:p>
-        </p:txBody>
-      </p:sp>
-      <p:sp>
-        <p:nvSpPr>
-          <p:cNvPr id="10" name="Shape 8"/>
-          <p:cNvSpPr/>
-          <p:nvPr/>
-        </p:nvSpPr>
-        <p:spPr>
-          <a:xfrm>
-            <a:off x="2075688" y="1115568"/>
-            <a:ext cx="1920240" cy="1143000"/>
-          </a:xfrm>
-          <a:prstGeom prst="rect">
-            <a:avLst/>
-          </a:prstGeom>
-          <a:solidFill>
-            <a:srgbClr val="FFFFFF"/>
-          </a:solidFill>
-          <a:ln w="12700">
-            <a:solidFill>
-              <a:srgbClr val="CBD5E1"/>
-            </a:solidFill>
-            <a:prstDash val="solid"/>
-          </a:ln>
-          <a:effectLst>
-            <a:outerShdw blurRad="76200" dist="25400" dir="8100000" algn="bl" rotWithShape="0">
-              <a:srgbClr val="000000">
-                <a:alpha val="8000"/>
-              </a:srgbClr>
-            </a:outerShdw>
-          </a:effectLst>
-        </p:spPr>
-      </p:sp>
-      <p:sp>
-        <p:nvSpPr>
-          <p:cNvPr id="11" name="Shape 9"/>
-          <p:cNvSpPr/>
-          <p:nvPr/>
-        </p:nvSpPr>
-        <p:spPr>
-          <a:xfrm>
-            <a:off x="2075688" y="1115568"/>
-            <a:ext cx="1920240" cy="201168"/>
-          </a:xfrm>
-          <a:prstGeom prst="rect">
-            <a:avLst/>
-          </a:prstGeom>
-          <a:solidFill>
-            <a:srgbClr val="1B3A6B"/>
-          </a:solidFill>
-          <a:ln w="12700">
-            <a:solidFill>
-              <a:srgbClr val="1B3A6B"/>
-            </a:solidFill>
-            <a:prstDash val="solid"/>
-          </a:ln>
-        </p:spPr>
-      </p:sp>
-      <p:sp>
-        <p:nvSpPr>
-          <p:cNvPr id="12" name="Text 10"/>
-          <p:cNvSpPr/>
-          <p:nvPr/>
-        </p:nvSpPr>
-        <p:spPr>
-          <a:xfrm>
-            <a:off x="2121408" y="1371600"/>
-            <a:ext cx="1828800" cy="566928"/>
-          </a:xfrm>
-          <a:prstGeom prst="rect">
-            <a:avLst/>
-          </a:prstGeom>
-          <a:noFill/>
-          <a:ln/>
-        </p:spPr>
-        <p:txBody>
-          <a:bodyPr wrap="square" lIns="0" tIns="0" rIns="0" bIns="0" rtlCol="0" anchor="ctr"/>
-          <a:lstStyle/>
-          <a:p>
-            <a:pPr marL="0" indent="0" algn="ctr">
-              <a:buNone/>
-            </a:pPr>
-            <a:r>
-              <a:rPr lang="en-US" sz="3200" b="1" dirty="0">
-                <a:solidFill>
-                  <a:srgbClr val="1B3A6B"/>
-                </a:solidFill>
-                <a:latin typeface="Calibri" pitchFamily="34" charset="0"/>
-                <a:ea typeface="Calibri" pitchFamily="34" charset="-122"/>
-                <a:cs typeface="Calibri" pitchFamily="34" charset="-120"/>
-              </a:rPr>
-              <a:t>10</a:t>
-            </a:r>
-            <a:endParaRPr lang="en-US" sz="3200" dirty="0"/>
-          </a:p>
-        </p:txBody>
-      </p:sp>
-      <p:sp>
-        <p:nvSpPr>
-          <p:cNvPr id="13" name="Text 11"/>
-          <p:cNvSpPr/>
-          <p:nvPr/>
-        </p:nvSpPr>
-        <p:spPr>
-          <a:xfrm>
-            <a:off x="2121408" y="1920240"/>
-            <a:ext cx="1828800" cy="292608"/>
-          </a:xfrm>
-          <a:prstGeom prst="rect">
-            <a:avLst/>
-          </a:prstGeom>
-          <a:noFill/>
-          <a:ln/>
-        </p:spPr>
-        <p:txBody>
-          <a:bodyPr wrap="square" lIns="0" tIns="0" rIns="0" bIns="0" rtlCol="0" anchor="ctr"/>
-          <a:lstStyle/>
-          <a:p>
-            <a:pPr marL="0" indent="0" algn="ctr">
-              <a:buNone/>
-            </a:pPr>
-            <a:r>
-              <a:rPr lang="en-US" sz="1000" dirty="0">
-                <a:solidFill>
-                  <a:srgbClr val="64748B"/>
-                </a:solidFill>
-                <a:latin typeface="Calibri" pitchFamily="34" charset="0"/>
-                <a:ea typeface="Calibri" pitchFamily="34" charset="-122"/>
-                <a:cs typeface="Calibri" pitchFamily="34" charset="-120"/>
-              </a:rPr>
-              <a:t>Charging Stations</a:t>
-            </a:r>
-            <a:endParaRPr lang="en-US" sz="1000" dirty="0"/>
-          </a:p>
-        </p:txBody>
-      </p:sp>
-      <p:sp>
-        <p:nvSpPr>
-          <p:cNvPr id="14" name="Shape 12"/>
-          <p:cNvSpPr/>
-          <p:nvPr/>
-        </p:nvSpPr>
-        <p:spPr>
-          <a:xfrm>
-            <a:off x="3831336" y="1115568"/>
-            <a:ext cx="1920240" cy="1143000"/>
-          </a:xfrm>
-          <a:prstGeom prst="rect">
-            <a:avLst/>
-          </a:prstGeom>
-          <a:solidFill>
-            <a:srgbClr val="FFFFFF"/>
-          </a:solidFill>
-          <a:ln w="12700">
-            <a:solidFill>
-              <a:srgbClr val="CBD5E1"/>
-            </a:solidFill>
-            <a:prstDash val="solid"/>
-          </a:ln>
-          <a:effectLst>
-            <a:outerShdw blurRad="76200" dist="25400" dir="8100000" algn="bl" rotWithShape="0">
-              <a:srgbClr val="000000">
-                <a:alpha val="8000"/>
-              </a:srgbClr>
-            </a:outerShdw>
-          </a:effectLst>
-        </p:spPr>
-      </p:sp>
-      <p:sp>
-        <p:nvSpPr>
-          <p:cNvPr id="15" name="Shape 13"/>
-          <p:cNvSpPr/>
-          <p:nvPr/>
-        </p:nvSpPr>
-        <p:spPr>
-          <a:xfrm>
-            <a:off x="3831336" y="1115568"/>
-            <a:ext cx="1920240" cy="201168"/>
-          </a:xfrm>
-          <a:prstGeom prst="rect">
-            <a:avLst/>
-          </a:prstGeom>
-          <a:solidFill>
-            <a:srgbClr val="0D7377"/>
-          </a:solidFill>
-          <a:ln w="12700">
-            <a:solidFill>
-              <a:srgbClr val="0D7377"/>
-            </a:solidFill>
-            <a:prstDash val="solid"/>
-          </a:ln>
-        </p:spPr>
-      </p:sp>
-      <p:sp>
-        <p:nvSpPr>
-          <p:cNvPr id="16" name="Text 14"/>
-          <p:cNvSpPr/>
-          <p:nvPr/>
-        </p:nvSpPr>
-        <p:spPr>
-          <a:xfrm>
-            <a:off x="3877056" y="1371600"/>
-            <a:ext cx="1828800" cy="566928"/>
-          </a:xfrm>
-          <a:prstGeom prst="rect">
-            <a:avLst/>
-          </a:prstGeom>
-          <a:noFill/>
-          <a:ln/>
-        </p:spPr>
-        <p:txBody>
-          <a:bodyPr wrap="square" lIns="0" tIns="0" rIns="0" bIns="0" rtlCol="0" anchor="ctr"/>
-          <a:lstStyle/>
-          <a:p>
-            <a:pPr marL="0" indent="0" algn="ctr">
-              <a:buNone/>
-            </a:pPr>
-            <a:r>
-              <a:rPr lang="en-US" sz="3200" b="1" dirty="0">
-                <a:solidFill>
-                  <a:srgbClr val="1B3A6B"/>
-                </a:solidFill>
-                <a:latin typeface="Calibri" pitchFamily="34" charset="0"/>
-                <a:ea typeface="Calibri" pitchFamily="34" charset="-122"/>
-                <a:cs typeface="Calibri" pitchFamily="34" charset="-120"/>
-              </a:rPr>
-              <a:t>49</a:t>
-            </a:r>
-            <a:endParaRPr lang="en-US" sz="3200" dirty="0"/>
-          </a:p>
-        </p:txBody>
-      </p:sp>
-      <p:sp>
-        <p:nvSpPr>
-          <p:cNvPr id="17" name="Text 15"/>
-          <p:cNvSpPr/>
-          <p:nvPr/>
-        </p:nvSpPr>
-        <p:spPr>
-          <a:xfrm>
-            <a:off x="3877056" y="1920240"/>
-            <a:ext cx="1828800" cy="292608"/>
-          </a:xfrm>
-          <a:prstGeom prst="rect">
-            <a:avLst/>
-          </a:prstGeom>
-          <a:noFill/>
-          <a:ln/>
-        </p:spPr>
-        <p:txBody>
-          <a:bodyPr wrap="square" lIns="0" tIns="0" rIns="0" bIns="0" rtlCol="0" anchor="ctr"/>
-          <a:lstStyle/>
-          <a:p>
-            <a:pPr marL="0" indent="0" algn="ctr">
-              <a:buNone/>
-            </a:pPr>
-            <a:r>
-              <a:rPr lang="en-US" sz="1000" dirty="0">
-                <a:solidFill>
-                  <a:srgbClr val="64748B"/>
-                </a:solidFill>
-                <a:latin typeface="Calibri" pitchFamily="34" charset="0"/>
-                <a:ea typeface="Calibri" pitchFamily="34" charset="-122"/>
-                <a:cs typeface="Calibri" pitchFamily="34" charset="-120"/>
-              </a:rPr>
-              <a:t>Electric Vehicles</a:t>
-            </a:r>
-            <a:endParaRPr lang="en-US" sz="1000" dirty="0"/>
-          </a:p>
-        </p:txBody>
-      </p:sp>
-      <p:sp>
-        <p:nvSpPr>
-          <p:cNvPr id="18" name="Shape 16"/>
-          <p:cNvSpPr/>
-          <p:nvPr/>
-        </p:nvSpPr>
-        <p:spPr>
-          <a:xfrm>
-            <a:off x="5586984" y="1115568"/>
-            <a:ext cx="1920240" cy="1143000"/>
-          </a:xfrm>
-          <a:prstGeom prst="rect">
-            <a:avLst/>
-          </a:prstGeom>
-          <a:solidFill>
-            <a:srgbClr val="FFFFFF"/>
-          </a:solidFill>
-          <a:ln w="12700">
-            <a:solidFill>
-              <a:srgbClr val="CBD5E1"/>
-            </a:solidFill>
-            <a:prstDash val="solid"/>
-          </a:ln>
-          <a:effectLst>
-            <a:outerShdw blurRad="76200" dist="25400" dir="8100000" algn="bl" rotWithShape="0">
-              <a:srgbClr val="000000">
-                <a:alpha val="8000"/>
-              </a:srgbClr>
-            </a:outerShdw>
-          </a:effectLst>
-        </p:spPr>
-      </p:sp>
-      <p:sp>
-        <p:nvSpPr>
-          <p:cNvPr id="19" name="Shape 17"/>
-          <p:cNvSpPr/>
-          <p:nvPr/>
-        </p:nvSpPr>
-        <p:spPr>
-          <a:xfrm>
-            <a:off x="5586984" y="1115568"/>
-            <a:ext cx="1920240" cy="201168"/>
-          </a:xfrm>
-          <a:prstGeom prst="rect">
-            <a:avLst/>
-          </a:prstGeom>
-          <a:solidFill>
-            <a:srgbClr val="1B3A6B"/>
-          </a:solidFill>
-          <a:ln w="12700">
-            <a:solidFill>
-              <a:srgbClr val="1B3A6B"/>
-            </a:solidFill>
-            <a:prstDash val="solid"/>
-          </a:ln>
-        </p:spPr>
-      </p:sp>
-      <p:sp>
-        <p:nvSpPr>
-          <p:cNvPr id="20" name="Text 18"/>
-          <p:cNvSpPr/>
-          <p:nvPr/>
-        </p:nvSpPr>
-        <p:spPr>
-          <a:xfrm>
-            <a:off x="5632704" y="1371600"/>
-            <a:ext cx="1828800" cy="566928"/>
-          </a:xfrm>
-          <a:prstGeom prst="rect">
-            <a:avLst/>
-          </a:prstGeom>
-          <a:noFill/>
-          <a:ln/>
-        </p:spPr>
-        <p:txBody>
-          <a:bodyPr wrap="square" lIns="0" tIns="0" rIns="0" bIns="0" rtlCol="0" anchor="ctr"/>
-          <a:lstStyle/>
-          <a:p>
-            <a:pPr marL="0" indent="0" algn="ctr">
-              <a:buNone/>
-            </a:pPr>
-            <a:r>
-              <a:rPr lang="en-US" sz="3200" b="1" dirty="0">
-                <a:solidFill>
-                  <a:srgbClr val="1B3A6B"/>
-                </a:solidFill>
-                <a:latin typeface="Calibri" pitchFamily="34" charset="0"/>
-                <a:ea typeface="Calibri" pitchFamily="34" charset="-122"/>
-                <a:cs typeface="Calibri" pitchFamily="34" charset="-120"/>
-              </a:rPr>
-              <a:t>600 s</a:t>
-            </a:r>
-            <a:endParaRPr lang="en-US" sz="3200" dirty="0"/>
-          </a:p>
-        </p:txBody>
-      </p:sp>
-      <p:sp>
-        <p:nvSpPr>
-          <p:cNvPr id="21" name="Text 19"/>
-          <p:cNvSpPr/>
-          <p:nvPr/>
-        </p:nvSpPr>
-        <p:spPr>
-          <a:xfrm>
-            <a:off x="5632704" y="1920240"/>
-            <a:ext cx="1828800" cy="292608"/>
-          </a:xfrm>
-          <a:prstGeom prst="rect">
-            <a:avLst/>
-          </a:prstGeom>
-          <a:noFill/>
-          <a:ln/>
-        </p:spPr>
-        <p:txBody>
-          <a:bodyPr wrap="square" lIns="0" tIns="0" rIns="0" bIns="0" rtlCol="0" anchor="ctr"/>
-          <a:lstStyle/>
-          <a:p>
-            <a:pPr marL="0" indent="0" algn="ctr">
-              <a:buNone/>
-            </a:pPr>
-            <a:r>
-              <a:rPr lang="en-US" sz="1000" dirty="0">
-                <a:solidFill>
-                  <a:srgbClr val="64748B"/>
-                </a:solidFill>
-                <a:latin typeface="Calibri" pitchFamily="34" charset="0"/>
-                <a:ea typeface="Calibri" pitchFamily="34" charset="-122"/>
-                <a:cs typeface="Calibri" pitchFamily="34" charset="-120"/>
-              </a:rPr>
-              <a:t>Simulation Duration</a:t>
-            </a:r>
-            <a:endParaRPr lang="en-US" sz="1000" dirty="0"/>
-          </a:p>
-        </p:txBody>
-      </p:sp>
-      <p:sp>
-        <p:nvSpPr>
-          <p:cNvPr id="22" name="Shape 20"/>
-          <p:cNvSpPr/>
-          <p:nvPr/>
-        </p:nvSpPr>
-        <p:spPr>
-          <a:xfrm>
-            <a:off x="7342632" y="1115568"/>
-            <a:ext cx="1481328" cy="1143000"/>
-          </a:xfrm>
-          <a:prstGeom prst="rect">
-            <a:avLst/>
-          </a:prstGeom>
-          <a:solidFill>
-            <a:srgbClr val="FFFFFF"/>
-          </a:solidFill>
-          <a:ln w="12700">
-            <a:solidFill>
-              <a:srgbClr val="CBD5E1"/>
-            </a:solidFill>
-            <a:prstDash val="solid"/>
-          </a:ln>
-          <a:effectLst>
-            <a:outerShdw blurRad="76200" dist="25400" dir="8100000" algn="bl" rotWithShape="0">
-              <a:srgbClr val="000000">
-                <a:alpha val="8000"/>
-              </a:srgbClr>
-            </a:outerShdw>
-          </a:effectLst>
-        </p:spPr>
-      </p:sp>
-      <p:sp>
-        <p:nvSpPr>
-          <p:cNvPr id="23" name="Shape 21"/>
-          <p:cNvSpPr/>
-          <p:nvPr/>
-        </p:nvSpPr>
-        <p:spPr>
-          <a:xfrm>
-            <a:off x="7342632" y="1115568"/>
-            <a:ext cx="1453896" cy="201168"/>
-          </a:xfrm>
-          <a:prstGeom prst="rect">
-            <a:avLst/>
-          </a:prstGeom>
-          <a:solidFill>
-            <a:srgbClr val="0D7377"/>
-          </a:solidFill>
-          <a:ln w="12700">
-            <a:solidFill>
-              <a:srgbClr val="0D7377"/>
-            </a:solidFill>
-            <a:prstDash val="solid"/>
-          </a:ln>
-        </p:spPr>
-      </p:sp>
-      <p:sp>
-        <p:nvSpPr>
-          <p:cNvPr id="24" name="Text 22"/>
-          <p:cNvSpPr/>
-          <p:nvPr/>
-        </p:nvSpPr>
-        <p:spPr>
-          <a:xfrm>
-            <a:off x="7388352" y="1371600"/>
-            <a:ext cx="1481328" cy="566928"/>
-          </a:xfrm>
-          <a:prstGeom prst="rect">
-            <a:avLst/>
-          </a:prstGeom>
-          <a:noFill/>
-          <a:ln/>
-        </p:spPr>
-        <p:txBody>
-          <a:bodyPr wrap="square" lIns="0" tIns="0" rIns="0" bIns="0" rtlCol="0" anchor="ctr"/>
-          <a:lstStyle/>
-          <a:p>
-            <a:pPr marL="0" indent="0" algn="ctr">
-              <a:buNone/>
-            </a:pPr>
-            <a:r>
-              <a:rPr lang="en-US" sz="3200" b="1" dirty="0">
-                <a:solidFill>
-                  <a:srgbClr val="1B3A6B"/>
-                </a:solidFill>
-                <a:latin typeface="Calibri" pitchFamily="34" charset="0"/>
-                <a:ea typeface="Calibri" pitchFamily="34" charset="-122"/>
-                <a:cs typeface="Calibri" pitchFamily="34" charset="-120"/>
-              </a:rPr>
-              <a:t>34,020</a:t>
-            </a:r>
-            <a:endParaRPr lang="en-US" sz="3200" dirty="0"/>
-          </a:p>
-        </p:txBody>
-      </p:sp>
-      <p:sp>
-        <p:nvSpPr>
-          <p:cNvPr id="25" name="Text 23"/>
-          <p:cNvSpPr/>
-          <p:nvPr/>
-        </p:nvSpPr>
-        <p:spPr>
-          <a:xfrm>
-            <a:off x="7388352" y="1920240"/>
-            <a:ext cx="1481328" cy="292608"/>
-          </a:xfrm>
-          <a:prstGeom prst="rect">
-            <a:avLst/>
-          </a:prstGeom>
-          <a:noFill/>
-          <a:ln/>
-        </p:spPr>
-        <p:txBody>
-          <a:bodyPr wrap="square" lIns="0" tIns="0" rIns="0" bIns="0" rtlCol="0" anchor="ctr"/>
-          <a:lstStyle/>
-          <a:p>
-            <a:pPr marL="0" indent="0" algn="ctr">
-              <a:buNone/>
-            </a:pPr>
-            <a:r>
-              <a:rPr lang="en-US" sz="1000" dirty="0">
-                <a:solidFill>
-                  <a:srgbClr val="64748B"/>
-                </a:solidFill>
-                <a:latin typeface="Calibri" pitchFamily="34" charset="0"/>
-                <a:ea typeface="Calibri" pitchFamily="34" charset="-122"/>
-                <a:cs typeface="Calibri" pitchFamily="34" charset="-120"/>
-              </a:rPr>
-              <a:t>Records Generated</a:t>
-            </a:r>
-            <a:endParaRPr lang="en-US" sz="1000" dirty="0"/>
-          </a:p>
-        </p:txBody>
-      </p:sp>
-      <p:sp>
-        <p:nvSpPr>
-          <p:cNvPr id="26" name="Shape 24"/>
-          <p:cNvSpPr/>
-          <p:nvPr/>
-        </p:nvSpPr>
-        <p:spPr>
-          <a:xfrm>
-            <a:off x="320040" y="2450592"/>
-            <a:ext cx="3931920" cy="2450592"/>
-          </a:xfrm>
-          <a:prstGeom prst="rect">
-            <a:avLst/>
-          </a:prstGeom>
-          <a:solidFill>
-            <a:srgbClr val="FFFFFF"/>
-          </a:solidFill>
-          <a:ln w="12700">
-            <a:solidFill>
-              <a:srgbClr val="CBD5E1"/>
-            </a:solidFill>
-            <a:prstDash val="solid"/>
-          </a:ln>
-          <a:effectLst>
-            <a:outerShdw blurRad="76200" dist="25400" dir="8100000" algn="bl" rotWithShape="0">
-              <a:srgbClr val="000000">
-                <a:alpha val="8000"/>
-              </a:srgbClr>
-            </a:outerShdw>
-          </a:effectLst>
-        </p:spPr>
-      </p:sp>
-      <p:pic>
-        <p:nvPicPr>
-          <p:cNvPr id="27" name="Image 0" descr="preencoded.png"/>
-          <p:cNvPicPr>
-            <a:picLocks noChangeAspect="1"/>
-          </p:cNvPicPr>
-          <p:nvPr/>
-        </p:nvPicPr>
-        <p:blipFill>
-          <a:blip r:embed="rId3"/>
-          <a:srcRect/>
-          <a:stretch/>
-        </p:blipFill>
-        <p:spPr>
-          <a:xfrm>
-            <a:off x="411480" y="2523744"/>
-            <a:ext cx="3749040" cy="2304288"/>
-          </a:xfrm>
-          <a:prstGeom prst="rect">
-            <a:avLst/>
-          </a:prstGeom>
-        </p:spPr>
-      </p:pic>
-      <p:sp>
-        <p:nvSpPr>
           <p:cNvPr id="28" name="Text 25"/>
           <p:cNvSpPr/>
           <p:nvPr/>
         </p:nvSpPr>
         <p:spPr>
           <a:xfrm>
-            <a:off x="320040" y="4846320"/>
+            <a:off x="320040" y="4887884"/>
             <a:ext cx="3931920" cy="228600"/>
           </a:xfrm>
           <a:prstGeom prst="rect">
@@ -27095,7 +26397,7 @@
         </p:nvSpPr>
         <p:spPr>
           <a:xfrm>
-            <a:off x="4434840" y="2450592"/>
+            <a:off x="4407408" y="1074420"/>
             <a:ext cx="4389120" cy="292608"/>
           </a:xfrm>
           <a:prstGeom prst="rect">
@@ -27128,56 +26430,64 @@
       </p:sp>
       <p:graphicFrame>
         <p:nvGraphicFramePr>
-          <p:cNvPr id="30" name="Table 0"/>
+          <p:cNvPr id="31" name="Table 30">
+            <a:extLst>
+              <a:ext uri="{FF2B5EF4-FFF2-40B4-BE49-F238E27FC236}">
+                <a16:creationId xmlns:a16="http://schemas.microsoft.com/office/drawing/2014/main" id="{41F96497-7750-3F8E-F9AB-94181039A7EF}"/>
+              </a:ext>
+            </a:extLst>
+          </p:cNvPr>
           <p:cNvGraphicFramePr>
             <a:graphicFrameLocks noGrp="1"/>
           </p:cNvGraphicFramePr>
           <p:nvPr>
             <p:extLst>
               <p:ext uri="{D42A27DB-BD31-4B8C-83A1-F6EECF244321}">
-                <p14:modId xmlns:p14="http://schemas.microsoft.com/office/powerpoint/2010/main" val="1579011935"/>
+                <p14:modId xmlns:p14="http://schemas.microsoft.com/office/powerpoint/2010/main" val="1285793762"/>
               </p:ext>
             </p:extLst>
           </p:nvPr>
         </p:nvGraphicFramePr>
         <p:xfrm>
-          <a:off x="4434840" y="2798064"/>
-          <a:ext cx="4361688" cy="2240280"/>
+          <a:off x="4343400" y="1426464"/>
+          <a:ext cx="4657201" cy="3474720"/>
         </p:xfrm>
         <a:graphic>
           <a:graphicData uri="http://schemas.openxmlformats.org/drawingml/2006/table">
             <a:tbl>
-              <a:tblPr/>
+              <a:tblPr firstRow="1" bandRow="1">
+                <a:tableStyleId>{5C22544A-7EE6-4342-B048-85BDC9FD1C3A}</a:tableStyleId>
+              </a:tblPr>
               <a:tblGrid>
-                <a:gridCol w="1051560">
+                <a:gridCol w="821859">
                   <a:extLst>
                     <a:ext uri="{9D8B030D-6E8A-4147-A177-3AD203B41FA5}">
                       <a16:colId xmlns:a16="http://schemas.microsoft.com/office/drawing/2014/main" val="20000"/>
                     </a:ext>
                   </a:extLst>
                 </a:gridCol>
-                <a:gridCol w="658368">
+                <a:gridCol w="821859">
                   <a:extLst>
                     <a:ext uri="{9D8B030D-6E8A-4147-A177-3AD203B41FA5}">
                       <a16:colId xmlns:a16="http://schemas.microsoft.com/office/drawing/2014/main" val="20001"/>
                     </a:ext>
                   </a:extLst>
                 </a:gridCol>
-                <a:gridCol w="822960">
+                <a:gridCol w="821859">
                   <a:extLst>
                     <a:ext uri="{9D8B030D-6E8A-4147-A177-3AD203B41FA5}">
                       <a16:colId xmlns:a16="http://schemas.microsoft.com/office/drawing/2014/main" val="20002"/>
                     </a:ext>
                   </a:extLst>
                 </a:gridCol>
-                <a:gridCol w="914400">
+                <a:gridCol w="1095812">
                   <a:extLst>
                     <a:ext uri="{9D8B030D-6E8A-4147-A177-3AD203B41FA5}">
                       <a16:colId xmlns:a16="http://schemas.microsoft.com/office/drawing/2014/main" val="20003"/>
                     </a:ext>
                   </a:extLst>
                 </a:gridCol>
-                <a:gridCol w="914400">
+                <a:gridCol w="1095812">
                   <a:extLst>
                     <a:ext uri="{9D8B030D-6E8A-4147-A177-3AD203B41FA5}">
                       <a16:colId xmlns:a16="http://schemas.microsoft.com/office/drawing/2014/main" val="20004"/>
@@ -27185,70 +26495,22 @@
                   </a:extLst>
                 </a:gridCol>
               </a:tblGrid>
-              <a:tr h="320040">
+              <a:tr h="378284">
                 <a:tc>
                   <a:txBody>
                     <a:bodyPr/>
                     <a:lstStyle/>
                     <a:p>
-                      <a:pPr marL="0" indent="0" algn="ctr">
-                        <a:buNone/>
+                      <a:pPr algn="ctr">
+                        <a:defRPr sz="1200" b="1"/>
                       </a:pPr>
                       <a:r>
-                        <a:rPr lang="en-US" sz="1100" b="1" dirty="0">
-                          <a:solidFill>
-                            <a:srgbClr val="FFFFFF"/>
-                          </a:solidFill>
-                          <a:latin typeface="Calibri" pitchFamily="34" charset="0"/>
-                          <a:ea typeface="Calibri" pitchFamily="34" charset="-122"/>
-                          <a:cs typeface="Calibri" pitchFamily="34" charset="-120"/>
-                        </a:rPr>
-                        <a:t>Station</a:t>
+                        <a:rPr dirty="0"/>
+                        <a:t>Station ID</a:t>
                       </a:r>
-                      <a:endParaRPr lang="en-US" sz="1100" dirty="0">
-                        <a:latin typeface="Calibri" charset="0"/>
-                        <a:ea typeface="Calibri" charset="0"/>
-                        <a:cs typeface="Calibri" charset="0"/>
-                      </a:endParaRPr>
                     </a:p>
                   </a:txBody>
                   <a:tcPr>
-                    <a:lnL w="6350" cap="flat" cmpd="sng" algn="ctr">
-                      <a:solidFill>
-                        <a:srgbClr val="CBD5E1"/>
-                      </a:solidFill>
-                      <a:prstDash val="solid"/>
-                      <a:round/>
-                      <a:headEnd type="none" w="med" len="med"/>
-                      <a:tailEnd type="none" w="med" len="med"/>
-                    </a:lnL>
-                    <a:lnR w="6350" cap="flat" cmpd="sng" algn="ctr">
-                      <a:solidFill>
-                        <a:srgbClr val="CBD5E1"/>
-                      </a:solidFill>
-                      <a:prstDash val="solid"/>
-                      <a:round/>
-                      <a:headEnd type="none" w="med" len="med"/>
-                      <a:tailEnd type="none" w="med" len="med"/>
-                    </a:lnR>
-                    <a:lnT w="6350" cap="flat" cmpd="sng" algn="ctr">
-                      <a:solidFill>
-                        <a:srgbClr val="CBD5E1"/>
-                      </a:solidFill>
-                      <a:prstDash val="solid"/>
-                      <a:round/>
-                      <a:headEnd type="none" w="med" len="med"/>
-                      <a:tailEnd type="none" w="med" len="med"/>
-                    </a:lnT>
-                    <a:lnB w="6350" cap="flat" cmpd="sng" algn="ctr">
-                      <a:solidFill>
-                        <a:srgbClr val="CBD5E1"/>
-                      </a:solidFill>
-                      <a:prstDash val="solid"/>
-                      <a:round/>
-                      <a:headEnd type="none" w="med" len="med"/>
-                      <a:tailEnd type="none" w="med" len="med"/>
-                    </a:lnB>
                     <a:solidFill>
                       <a:srgbClr val="1B3A6B"/>
                     </a:solidFill>
@@ -27259,64 +26521,15 @@
                     <a:bodyPr/>
                     <a:lstStyle/>
                     <a:p>
-                      <a:pPr marL="0" indent="0" algn="ctr">
-                        <a:buNone/>
+                      <a:pPr algn="ctr">
+                        <a:defRPr sz="1200" b="1"/>
                       </a:pPr>
                       <a:r>
-                        <a:rPr lang="en-US" sz="1100" b="1" dirty="0">
-                          <a:solidFill>
-                            <a:srgbClr val="FFFFFF"/>
-                          </a:solidFill>
-                          <a:latin typeface="Calibri" pitchFamily="34" charset="0"/>
-                          <a:ea typeface="Calibri" pitchFamily="34" charset="-122"/>
-                          <a:cs typeface="Calibri" pitchFamily="34" charset="-120"/>
-                        </a:rPr>
-                        <a:t>Edge</a:t>
+                        <a:t>Edge ID</a:t>
                       </a:r>
-                      <a:endParaRPr lang="en-US" sz="1100" dirty="0">
-                        <a:latin typeface="Calibri" charset="0"/>
-                        <a:ea typeface="Calibri" charset="0"/>
-                        <a:cs typeface="Calibri" charset="0"/>
-                      </a:endParaRPr>
                     </a:p>
                   </a:txBody>
                   <a:tcPr>
-                    <a:lnL w="6350" cap="flat" cmpd="sng" algn="ctr">
-                      <a:solidFill>
-                        <a:srgbClr val="CBD5E1"/>
-                      </a:solidFill>
-                      <a:prstDash val="solid"/>
-                      <a:round/>
-                      <a:headEnd type="none" w="med" len="med"/>
-                      <a:tailEnd type="none" w="med" len="med"/>
-                    </a:lnL>
-                    <a:lnR w="6350" cap="flat" cmpd="sng" algn="ctr">
-                      <a:solidFill>
-                        <a:srgbClr val="CBD5E1"/>
-                      </a:solidFill>
-                      <a:prstDash val="solid"/>
-                      <a:round/>
-                      <a:headEnd type="none" w="med" len="med"/>
-                      <a:tailEnd type="none" w="med" len="med"/>
-                    </a:lnR>
-                    <a:lnT w="6350" cap="flat" cmpd="sng" algn="ctr">
-                      <a:solidFill>
-                        <a:srgbClr val="CBD5E1"/>
-                      </a:solidFill>
-                      <a:prstDash val="solid"/>
-                      <a:round/>
-                      <a:headEnd type="none" w="med" len="med"/>
-                      <a:tailEnd type="none" w="med" len="med"/>
-                    </a:lnT>
-                    <a:lnB w="6350" cap="flat" cmpd="sng" algn="ctr">
-                      <a:solidFill>
-                        <a:srgbClr val="CBD5E1"/>
-                      </a:solidFill>
-                      <a:prstDash val="solid"/>
-                      <a:round/>
-                      <a:headEnd type="none" w="med" len="med"/>
-                      <a:tailEnd type="none" w="med" len="med"/>
-                    </a:lnB>
                     <a:solidFill>
                       <a:srgbClr val="1B3A6B"/>
                     </a:solidFill>
@@ -27327,64 +26540,16 @@
                     <a:bodyPr/>
                     <a:lstStyle/>
                     <a:p>
-                      <a:pPr marL="0" indent="0" algn="ctr">
-                        <a:buNone/>
+                      <a:pPr algn="ctr">
+                        <a:defRPr sz="1200" b="1"/>
                       </a:pPr>
                       <a:r>
-                        <a:rPr lang="en-US" sz="1100" b="1" dirty="0">
-                          <a:solidFill>
-                            <a:srgbClr val="FFFFFF"/>
-                          </a:solidFill>
-                          <a:latin typeface="Calibri" pitchFamily="34" charset="0"/>
-                          <a:ea typeface="Calibri" pitchFamily="34" charset="-122"/>
-                          <a:cs typeface="Calibri" pitchFamily="34" charset="-120"/>
-                        </a:rPr>
-                        <a:t>Power</a:t>
+                        <a:rPr dirty="0"/>
+                        <a:t>Power (kW)</a:t>
                       </a:r>
-                      <a:endParaRPr lang="en-US" sz="1100" dirty="0">
-                        <a:latin typeface="Calibri" charset="0"/>
-                        <a:ea typeface="Calibri" charset="0"/>
-                        <a:cs typeface="Calibri" charset="0"/>
-                      </a:endParaRPr>
                     </a:p>
                   </a:txBody>
                   <a:tcPr>
-                    <a:lnL w="6350" cap="flat" cmpd="sng" algn="ctr">
-                      <a:solidFill>
-                        <a:srgbClr val="CBD5E1"/>
-                      </a:solidFill>
-                      <a:prstDash val="solid"/>
-                      <a:round/>
-                      <a:headEnd type="none" w="med" len="med"/>
-                      <a:tailEnd type="none" w="med" len="med"/>
-                    </a:lnL>
-                    <a:lnR w="6350" cap="flat" cmpd="sng" algn="ctr">
-                      <a:solidFill>
-                        <a:srgbClr val="CBD5E1"/>
-                      </a:solidFill>
-                      <a:prstDash val="solid"/>
-                      <a:round/>
-                      <a:headEnd type="none" w="med" len="med"/>
-                      <a:tailEnd type="none" w="med" len="med"/>
-                    </a:lnR>
-                    <a:lnT w="6350" cap="flat" cmpd="sng" algn="ctr">
-                      <a:solidFill>
-                        <a:srgbClr val="CBD5E1"/>
-                      </a:solidFill>
-                      <a:prstDash val="solid"/>
-                      <a:round/>
-                      <a:headEnd type="none" w="med" len="med"/>
-                      <a:tailEnd type="none" w="med" len="med"/>
-                    </a:lnT>
-                    <a:lnB w="6350" cap="flat" cmpd="sng" algn="ctr">
-                      <a:solidFill>
-                        <a:srgbClr val="CBD5E1"/>
-                      </a:solidFill>
-                      <a:prstDash val="solid"/>
-                      <a:round/>
-                      <a:headEnd type="none" w="med" len="med"/>
-                      <a:tailEnd type="none" w="med" len="med"/>
-                    </a:lnB>
                     <a:solidFill>
                       <a:srgbClr val="1B3A6B"/>
                     </a:solidFill>
@@ -27395,64 +26560,15 @@
                     <a:bodyPr/>
                     <a:lstStyle/>
                     <a:p>
-                      <a:pPr marL="0" indent="0" algn="ctr">
-                        <a:buNone/>
+                      <a:pPr algn="ctr">
+                        <a:defRPr sz="1200" b="1"/>
                       </a:pPr>
                       <a:r>
-                        <a:rPr lang="en-US" sz="1100" b="1" dirty="0">
-                          <a:solidFill>
-                            <a:srgbClr val="FFFFFF"/>
-                          </a:solidFill>
-                          <a:latin typeface="Calibri" pitchFamily="34" charset="0"/>
-                          <a:ea typeface="Calibri" pitchFamily="34" charset="-122"/>
-                          <a:cs typeface="Calibri" pitchFamily="34" charset="-120"/>
-                        </a:rPr>
-                        <a:t>Chg Slots</a:t>
+                        <a:t>Charging Slots</a:t>
                       </a:r>
-                      <a:endParaRPr lang="en-US" sz="1100" dirty="0">
-                        <a:latin typeface="Calibri" charset="0"/>
-                        <a:ea typeface="Calibri" charset="0"/>
-                        <a:cs typeface="Calibri" charset="0"/>
-                      </a:endParaRPr>
                     </a:p>
                   </a:txBody>
                   <a:tcPr>
-                    <a:lnL w="6350" cap="flat" cmpd="sng" algn="ctr">
-                      <a:solidFill>
-                        <a:srgbClr val="CBD5E1"/>
-                      </a:solidFill>
-                      <a:prstDash val="solid"/>
-                      <a:round/>
-                      <a:headEnd type="none" w="med" len="med"/>
-                      <a:tailEnd type="none" w="med" len="med"/>
-                    </a:lnL>
-                    <a:lnR w="6350" cap="flat" cmpd="sng" algn="ctr">
-                      <a:solidFill>
-                        <a:srgbClr val="CBD5E1"/>
-                      </a:solidFill>
-                      <a:prstDash val="solid"/>
-                      <a:round/>
-                      <a:headEnd type="none" w="med" len="med"/>
-                      <a:tailEnd type="none" w="med" len="med"/>
-                    </a:lnR>
-                    <a:lnT w="6350" cap="flat" cmpd="sng" algn="ctr">
-                      <a:solidFill>
-                        <a:srgbClr val="CBD5E1"/>
-                      </a:solidFill>
-                      <a:prstDash val="solid"/>
-                      <a:round/>
-                      <a:headEnd type="none" w="med" len="med"/>
-                      <a:tailEnd type="none" w="med" len="med"/>
-                    </a:lnT>
-                    <a:lnB w="6350" cap="flat" cmpd="sng" algn="ctr">
-                      <a:solidFill>
-                        <a:srgbClr val="CBD5E1"/>
-                      </a:solidFill>
-                      <a:prstDash val="solid"/>
-                      <a:round/>
-                      <a:headEnd type="none" w="med" len="med"/>
-                      <a:tailEnd type="none" w="med" len="med"/>
-                    </a:lnB>
                     <a:solidFill>
                       <a:srgbClr val="1B3A6B"/>
                     </a:solidFill>
@@ -27463,64 +26579,16 @@
                     <a:bodyPr/>
                     <a:lstStyle/>
                     <a:p>
-                      <a:pPr marL="0" indent="0" algn="ctr">
-                        <a:buNone/>
+                      <a:pPr algn="ctr">
+                        <a:defRPr sz="1200" b="1"/>
                       </a:pPr>
                       <a:r>
-                        <a:rPr lang="en-US" sz="1100" b="1" dirty="0">
-                          <a:solidFill>
-                            <a:srgbClr val="FFFFFF"/>
-                          </a:solidFill>
-                          <a:latin typeface="Calibri" pitchFamily="34" charset="0"/>
-                          <a:ea typeface="Calibri" pitchFamily="34" charset="-122"/>
-                          <a:cs typeface="Calibri" pitchFamily="34" charset="-120"/>
-                        </a:rPr>
-                        <a:t>Wait Slots</a:t>
+                        <a:rPr dirty="0"/>
+                        <a:t>Waiting Slots</a:t>
                       </a:r>
-                      <a:endParaRPr lang="en-US" sz="1100" dirty="0">
-                        <a:latin typeface="Calibri" charset="0"/>
-                        <a:ea typeface="Calibri" charset="0"/>
-                        <a:cs typeface="Calibri" charset="0"/>
-                      </a:endParaRPr>
                     </a:p>
                   </a:txBody>
                   <a:tcPr>
-                    <a:lnL w="6350" cap="flat" cmpd="sng" algn="ctr">
-                      <a:solidFill>
-                        <a:srgbClr val="CBD5E1"/>
-                      </a:solidFill>
-                      <a:prstDash val="solid"/>
-                      <a:round/>
-                      <a:headEnd type="none" w="med" len="med"/>
-                      <a:tailEnd type="none" w="med" len="med"/>
-                    </a:lnL>
-                    <a:lnR w="6350" cap="flat" cmpd="sng" algn="ctr">
-                      <a:solidFill>
-                        <a:srgbClr val="CBD5E1"/>
-                      </a:solidFill>
-                      <a:prstDash val="solid"/>
-                      <a:round/>
-                      <a:headEnd type="none" w="med" len="med"/>
-                      <a:tailEnd type="none" w="med" len="med"/>
-                    </a:lnR>
-                    <a:lnT w="6350" cap="flat" cmpd="sng" algn="ctr">
-                      <a:solidFill>
-                        <a:srgbClr val="CBD5E1"/>
-                      </a:solidFill>
-                      <a:prstDash val="solid"/>
-                      <a:round/>
-                      <a:headEnd type="none" w="med" len="med"/>
-                      <a:tailEnd type="none" w="med" len="med"/>
-                    </a:lnT>
-                    <a:lnB w="6350" cap="flat" cmpd="sng" algn="ctr">
-                      <a:solidFill>
-                        <a:srgbClr val="CBD5E1"/>
-                      </a:solidFill>
-                      <a:prstDash val="solid"/>
-                      <a:round/>
-                      <a:headEnd type="none" w="med" len="med"/>
-                      <a:tailEnd type="none" w="med" len="med"/>
-                    </a:lnB>
                     <a:solidFill>
                       <a:srgbClr val="1B3A6B"/>
                     </a:solidFill>
@@ -27532,331 +26600,83 @@
                   </a:ext>
                 </a:extLst>
               </a:tr>
-              <a:tr h="320040">
+              <a:tr h="226970">
                 <a:tc>
                   <a:txBody>
                     <a:bodyPr/>
                     <a:lstStyle/>
                     <a:p>
-                      <a:pPr marL="0" indent="0" algn="ctr">
-                        <a:buNone/>
+                      <a:pPr algn="ctr">
+                        <a:defRPr sz="1200"/>
                       </a:pPr>
                       <a:r>
-                        <a:rPr lang="en-US" sz="1100" dirty="0">
-                          <a:solidFill>
-                            <a:srgbClr val="000000"/>
-                          </a:solidFill>
-                          <a:latin typeface="Calibri" pitchFamily="34" charset="0"/>
-                          <a:ea typeface="Calibri" pitchFamily="34" charset="-122"/>
-                          <a:cs typeface="Calibri" pitchFamily="34" charset="-120"/>
-                        </a:rPr>
                         <a:t>pa_2</a:t>
                       </a:r>
-                      <a:endParaRPr lang="en-US" sz="1100" dirty="0">
-                        <a:latin typeface="Calibri" charset="0"/>
-                        <a:ea typeface="Calibri" charset="0"/>
-                        <a:cs typeface="Calibri" charset="0"/>
-                      </a:endParaRPr>
                     </a:p>
                   </a:txBody>
-                  <a:tcPr>
-                    <a:lnL w="6350" cap="flat" cmpd="sng" algn="ctr">
-                      <a:solidFill>
-                        <a:srgbClr val="CBD5E1"/>
-                      </a:solidFill>
-                      <a:prstDash val="solid"/>
-                      <a:round/>
-                      <a:headEnd type="none" w="med" len="med"/>
-                      <a:tailEnd type="none" w="med" len="med"/>
-                    </a:lnL>
-                    <a:lnR w="6350" cap="flat" cmpd="sng" algn="ctr">
-                      <a:solidFill>
-                        <a:srgbClr val="CBD5E1"/>
-                      </a:solidFill>
-                      <a:prstDash val="solid"/>
-                      <a:round/>
-                      <a:headEnd type="none" w="med" len="med"/>
-                      <a:tailEnd type="none" w="med" len="med"/>
-                    </a:lnR>
-                    <a:lnT w="6350" cap="flat" cmpd="sng" algn="ctr">
-                      <a:solidFill>
-                        <a:srgbClr val="CBD5E1"/>
-                      </a:solidFill>
-                      <a:prstDash val="solid"/>
-                      <a:round/>
-                      <a:headEnd type="none" w="med" len="med"/>
-                      <a:tailEnd type="none" w="med" len="med"/>
-                    </a:lnT>
-                    <a:lnB w="6350" cap="flat" cmpd="sng" algn="ctr">
-                      <a:solidFill>
-                        <a:srgbClr val="CBD5E1"/>
-                      </a:solidFill>
-                      <a:prstDash val="solid"/>
-                      <a:round/>
-                      <a:headEnd type="none" w="med" len="med"/>
-                      <a:tailEnd type="none" w="med" len="med"/>
-                    </a:lnB>
-                  </a:tcPr>
+                  <a:tcPr/>
                 </a:tc>
                 <a:tc>
                   <a:txBody>
                     <a:bodyPr/>
                     <a:lstStyle/>
                     <a:p>
-                      <a:pPr marL="0" indent="0" algn="ctr">
-                        <a:buNone/>
+                      <a:pPr algn="ctr">
+                        <a:defRPr sz="1200"/>
                       </a:pPr>
                       <a:r>
-                        <a:rPr lang="en-US" sz="1100" dirty="0">
-                          <a:solidFill>
-                            <a:srgbClr val="000000"/>
-                          </a:solidFill>
-                          <a:latin typeface="Calibri" pitchFamily="34" charset="0"/>
-                          <a:ea typeface="Calibri" pitchFamily="34" charset="-122"/>
-                          <a:cs typeface="Calibri" pitchFamily="34" charset="-120"/>
-                        </a:rPr>
                         <a:t>E0</a:t>
                       </a:r>
-                      <a:endParaRPr lang="en-US" sz="1100" dirty="0">
-                        <a:latin typeface="Calibri" charset="0"/>
-                        <a:ea typeface="Calibri" charset="0"/>
-                        <a:cs typeface="Calibri" charset="0"/>
-                      </a:endParaRPr>
                     </a:p>
                   </a:txBody>
-                  <a:tcPr>
-                    <a:lnL w="6350" cap="flat" cmpd="sng" algn="ctr">
-                      <a:solidFill>
-                        <a:srgbClr val="CBD5E1"/>
-                      </a:solidFill>
-                      <a:prstDash val="solid"/>
-                      <a:round/>
-                      <a:headEnd type="none" w="med" len="med"/>
-                      <a:tailEnd type="none" w="med" len="med"/>
-                    </a:lnL>
-                    <a:lnR w="6350" cap="flat" cmpd="sng" algn="ctr">
-                      <a:solidFill>
-                        <a:srgbClr val="CBD5E1"/>
-                      </a:solidFill>
-                      <a:prstDash val="solid"/>
-                      <a:round/>
-                      <a:headEnd type="none" w="med" len="med"/>
-                      <a:tailEnd type="none" w="med" len="med"/>
-                    </a:lnR>
-                    <a:lnT w="6350" cap="flat" cmpd="sng" algn="ctr">
-                      <a:solidFill>
-                        <a:srgbClr val="CBD5E1"/>
-                      </a:solidFill>
-                      <a:prstDash val="solid"/>
-                      <a:round/>
-                      <a:headEnd type="none" w="med" len="med"/>
-                      <a:tailEnd type="none" w="med" len="med"/>
-                    </a:lnT>
-                    <a:lnB w="6350" cap="flat" cmpd="sng" algn="ctr">
-                      <a:solidFill>
-                        <a:srgbClr val="CBD5E1"/>
-                      </a:solidFill>
-                      <a:prstDash val="solid"/>
-                      <a:round/>
-                      <a:headEnd type="none" w="med" len="med"/>
-                      <a:tailEnd type="none" w="med" len="med"/>
-                    </a:lnB>
-                  </a:tcPr>
+                  <a:tcPr/>
                 </a:tc>
                 <a:tc>
                   <a:txBody>
                     <a:bodyPr/>
                     <a:lstStyle/>
                     <a:p>
-                      <a:pPr marL="0" indent="0" algn="ctr">
-                        <a:buNone/>
+                      <a:pPr algn="ctr">
+                        <a:defRPr sz="1200"/>
                       </a:pPr>
                       <a:r>
-                        <a:rPr lang="en-US" sz="1100" dirty="0">
-                          <a:solidFill>
-                            <a:srgbClr val="000000"/>
-                          </a:solidFill>
-                          <a:latin typeface="Calibri" pitchFamily="34" charset="0"/>
-                          <a:ea typeface="Calibri" pitchFamily="34" charset="-122"/>
-                          <a:cs typeface="Calibri" pitchFamily="34" charset="-120"/>
-                        </a:rPr>
-                        <a:t>30 kW</a:t>
+                        <a:t>30</a:t>
                       </a:r>
-                      <a:endParaRPr lang="en-US" sz="1100" dirty="0">
-                        <a:latin typeface="Calibri" charset="0"/>
-                        <a:ea typeface="Calibri" charset="0"/>
-                        <a:cs typeface="Calibri" charset="0"/>
-                      </a:endParaRPr>
                     </a:p>
                   </a:txBody>
-                  <a:tcPr>
-                    <a:lnL w="6350" cap="flat" cmpd="sng" algn="ctr">
-                      <a:solidFill>
-                        <a:srgbClr val="CBD5E1"/>
-                      </a:solidFill>
-                      <a:prstDash val="solid"/>
-                      <a:round/>
-                      <a:headEnd type="none" w="med" len="med"/>
-                      <a:tailEnd type="none" w="med" len="med"/>
-                    </a:lnL>
-                    <a:lnR w="6350" cap="flat" cmpd="sng" algn="ctr">
-                      <a:solidFill>
-                        <a:srgbClr val="CBD5E1"/>
-                      </a:solidFill>
-                      <a:prstDash val="solid"/>
-                      <a:round/>
-                      <a:headEnd type="none" w="med" len="med"/>
-                      <a:tailEnd type="none" w="med" len="med"/>
-                    </a:lnR>
-                    <a:lnT w="6350" cap="flat" cmpd="sng" algn="ctr">
-                      <a:solidFill>
-                        <a:srgbClr val="CBD5E1"/>
-                      </a:solidFill>
-                      <a:prstDash val="solid"/>
-                      <a:round/>
-                      <a:headEnd type="none" w="med" len="med"/>
-                      <a:tailEnd type="none" w="med" len="med"/>
-                    </a:lnT>
-                    <a:lnB w="6350" cap="flat" cmpd="sng" algn="ctr">
-                      <a:solidFill>
-                        <a:srgbClr val="CBD5E1"/>
-                      </a:solidFill>
-                      <a:prstDash val="solid"/>
-                      <a:round/>
-                      <a:headEnd type="none" w="med" len="med"/>
-                      <a:tailEnd type="none" w="med" len="med"/>
-                    </a:lnB>
-                  </a:tcPr>
+                  <a:tcPr/>
                 </a:tc>
                 <a:tc>
                   <a:txBody>
                     <a:bodyPr/>
                     <a:lstStyle/>
                     <a:p>
-                      <a:pPr marL="0" indent="0" algn="ctr">
-                        <a:buNone/>
+                      <a:pPr algn="ctr">
+                        <a:defRPr sz="1200"/>
                       </a:pPr>
                       <a:r>
-                        <a:rPr lang="en-US" sz="1100" dirty="0">
-                          <a:solidFill>
-                            <a:srgbClr val="000000"/>
-                          </a:solidFill>
-                          <a:latin typeface="Calibri" pitchFamily="34" charset="0"/>
-                          <a:ea typeface="Calibri" pitchFamily="34" charset="-122"/>
-                          <a:cs typeface="Calibri" pitchFamily="34" charset="-120"/>
-                        </a:rPr>
+                        <a:rPr dirty="0"/>
                         <a:t>6</a:t>
                       </a:r>
-                      <a:endParaRPr lang="en-US" sz="1100" dirty="0">
-                        <a:latin typeface="Calibri" charset="0"/>
-                        <a:ea typeface="Calibri" charset="0"/>
-                        <a:cs typeface="Calibri" charset="0"/>
-                      </a:endParaRPr>
                     </a:p>
                   </a:txBody>
-                  <a:tcPr>
-                    <a:lnL w="6350" cap="flat" cmpd="sng" algn="ctr">
-                      <a:solidFill>
-                        <a:srgbClr val="CBD5E1"/>
-                      </a:solidFill>
-                      <a:prstDash val="solid"/>
-                      <a:round/>
-                      <a:headEnd type="none" w="med" len="med"/>
-                      <a:tailEnd type="none" w="med" len="med"/>
-                    </a:lnL>
-                    <a:lnR w="6350" cap="flat" cmpd="sng" algn="ctr">
-                      <a:solidFill>
-                        <a:srgbClr val="CBD5E1"/>
-                      </a:solidFill>
-                      <a:prstDash val="solid"/>
-                      <a:round/>
-                      <a:headEnd type="none" w="med" len="med"/>
-                      <a:tailEnd type="none" w="med" len="med"/>
-                    </a:lnR>
-                    <a:lnT w="6350" cap="flat" cmpd="sng" algn="ctr">
-                      <a:solidFill>
-                        <a:srgbClr val="CBD5E1"/>
-                      </a:solidFill>
-                      <a:prstDash val="solid"/>
-                      <a:round/>
-                      <a:headEnd type="none" w="med" len="med"/>
-                      <a:tailEnd type="none" w="med" len="med"/>
-                    </a:lnT>
-                    <a:lnB w="6350" cap="flat" cmpd="sng" algn="ctr">
-                      <a:solidFill>
-                        <a:srgbClr val="CBD5E1"/>
-                      </a:solidFill>
-                      <a:prstDash val="solid"/>
-                      <a:round/>
-                      <a:headEnd type="none" w="med" len="med"/>
-                      <a:tailEnd type="none" w="med" len="med"/>
-                    </a:lnB>
-                  </a:tcPr>
+                  <a:tcPr/>
                 </a:tc>
                 <a:tc>
                   <a:txBody>
                     <a:bodyPr/>
                     <a:lstStyle/>
                     <a:p>
-                      <a:pPr marL="0" indent="0" algn="ctr">
-                        <a:buNone/>
+                      <a:pPr algn="ctr">
+                        <a:defRPr sz="1200"/>
                       </a:pPr>
                       <a:r>
-                        <a:rPr lang="en-US" sz="1100" dirty="0">
-                          <a:solidFill>
-                            <a:srgbClr val="000000"/>
-                          </a:solidFill>
-                          <a:latin typeface="Calibri" pitchFamily="34" charset="0"/>
-                          <a:ea typeface="Calibri" pitchFamily="34" charset="-122"/>
-                          <a:cs typeface="Calibri" pitchFamily="34" charset="-120"/>
-                        </a:rPr>
+                        <a:rPr dirty="0"/>
                         <a:t>6</a:t>
                       </a:r>
-                      <a:endParaRPr lang="en-US" sz="1100" dirty="0">
-                        <a:latin typeface="Calibri" charset="0"/>
-                        <a:ea typeface="Calibri" charset="0"/>
-                        <a:cs typeface="Calibri" charset="0"/>
-                      </a:endParaRPr>
                     </a:p>
                   </a:txBody>
-                  <a:tcPr>
-                    <a:lnL w="6350" cap="flat" cmpd="sng" algn="ctr">
-                      <a:solidFill>
-                        <a:srgbClr val="CBD5E1"/>
-                      </a:solidFill>
-                      <a:prstDash val="solid"/>
-                      <a:round/>
-                      <a:headEnd type="none" w="med" len="med"/>
-                      <a:tailEnd type="none" w="med" len="med"/>
-                    </a:lnL>
-                    <a:lnR w="6350" cap="flat" cmpd="sng" algn="ctr">
-                      <a:solidFill>
-                        <a:srgbClr val="CBD5E1"/>
-                      </a:solidFill>
-                      <a:prstDash val="solid"/>
-                      <a:round/>
-                      <a:headEnd type="none" w="med" len="med"/>
-                      <a:tailEnd type="none" w="med" len="med"/>
-                    </a:lnR>
-                    <a:lnT w="6350" cap="flat" cmpd="sng" algn="ctr">
-                      <a:solidFill>
-                        <a:srgbClr val="CBD5E1"/>
-                      </a:solidFill>
-                      <a:prstDash val="solid"/>
-                      <a:round/>
-                      <a:headEnd type="none" w="med" len="med"/>
-                      <a:tailEnd type="none" w="med" len="med"/>
-                    </a:lnT>
-                    <a:lnB w="6350" cap="flat" cmpd="sng" algn="ctr">
-                      <a:solidFill>
-                        <a:srgbClr val="CBD5E1"/>
-                      </a:solidFill>
-                      <a:prstDash val="solid"/>
-                      <a:round/>
-                      <a:headEnd type="none" w="med" len="med"/>
-                      <a:tailEnd type="none" w="med" len="med"/>
-                    </a:lnB>
-                  </a:tcPr>
+                  <a:tcPr/>
                 </a:tc>
                 <a:extLst>
                   <a:ext uri="{0D108BD9-81ED-4DB2-BD59-A6C34878D82A}">
@@ -27864,331 +26684,81 @@
                   </a:ext>
                 </a:extLst>
               </a:tr>
-              <a:tr h="320040">
+              <a:tr h="226970">
                 <a:tc>
                   <a:txBody>
                     <a:bodyPr/>
                     <a:lstStyle/>
                     <a:p>
-                      <a:pPr marL="0" indent="0" algn="ctr">
-                        <a:buNone/>
+                      <a:pPr algn="ctr">
+                        <a:defRPr sz="1200"/>
                       </a:pPr>
                       <a:r>
-                        <a:rPr lang="en-US" sz="1100" dirty="0">
-                          <a:solidFill>
-                            <a:srgbClr val="000000"/>
-                          </a:solidFill>
-                          <a:latin typeface="Calibri" pitchFamily="34" charset="0"/>
-                          <a:ea typeface="Calibri" pitchFamily="34" charset="-122"/>
-                          <a:cs typeface="Calibri" pitchFamily="34" charset="-120"/>
-                        </a:rPr>
-                        <a:t>pa_3</a:t>
+                        <a:t>pa_2_rev</a:t>
                       </a:r>
-                      <a:endParaRPr lang="en-US" sz="1100" dirty="0">
-                        <a:latin typeface="Calibri" charset="0"/>
-                        <a:ea typeface="Calibri" charset="0"/>
-                        <a:cs typeface="Calibri" charset="0"/>
-                      </a:endParaRPr>
                     </a:p>
                   </a:txBody>
-                  <a:tcPr>
-                    <a:lnL w="6350" cap="flat" cmpd="sng" algn="ctr">
-                      <a:solidFill>
-                        <a:srgbClr val="CBD5E1"/>
-                      </a:solidFill>
-                      <a:prstDash val="solid"/>
-                      <a:round/>
-                      <a:headEnd type="none" w="med" len="med"/>
-                      <a:tailEnd type="none" w="med" len="med"/>
-                    </a:lnL>
-                    <a:lnR w="6350" cap="flat" cmpd="sng" algn="ctr">
-                      <a:solidFill>
-                        <a:srgbClr val="CBD5E1"/>
-                      </a:solidFill>
-                      <a:prstDash val="solid"/>
-                      <a:round/>
-                      <a:headEnd type="none" w="med" len="med"/>
-                      <a:tailEnd type="none" w="med" len="med"/>
-                    </a:lnR>
-                    <a:lnT w="6350" cap="flat" cmpd="sng" algn="ctr">
-                      <a:solidFill>
-                        <a:srgbClr val="CBD5E1"/>
-                      </a:solidFill>
-                      <a:prstDash val="solid"/>
-                      <a:round/>
-                      <a:headEnd type="none" w="med" len="med"/>
-                      <a:tailEnd type="none" w="med" len="med"/>
-                    </a:lnT>
-                    <a:lnB w="6350" cap="flat" cmpd="sng" algn="ctr">
-                      <a:solidFill>
-                        <a:srgbClr val="CBD5E1"/>
-                      </a:solidFill>
-                      <a:prstDash val="solid"/>
-                      <a:round/>
-                      <a:headEnd type="none" w="med" len="med"/>
-                      <a:tailEnd type="none" w="med" len="med"/>
-                    </a:lnB>
-                  </a:tcPr>
+                  <a:tcPr/>
                 </a:tc>
                 <a:tc>
                   <a:txBody>
                     <a:bodyPr/>
                     <a:lstStyle/>
                     <a:p>
-                      <a:pPr marL="0" indent="0" algn="ctr">
-                        <a:buNone/>
+                      <a:pPr algn="ctr">
+                        <a:defRPr sz="1200"/>
                       </a:pPr>
                       <a:r>
-                        <a:rPr lang="en-US" sz="1100" dirty="0">
-                          <a:solidFill>
-                            <a:srgbClr val="000000"/>
-                          </a:solidFill>
-                          <a:latin typeface="Calibri" pitchFamily="34" charset="0"/>
-                          <a:ea typeface="Calibri" pitchFamily="34" charset="-122"/>
-                          <a:cs typeface="Calibri" pitchFamily="34" charset="-120"/>
-                        </a:rPr>
-                        <a:t>E1</a:t>
+                        <a:t>-E0</a:t>
                       </a:r>
-                      <a:endParaRPr lang="en-US" sz="1100" dirty="0">
-                        <a:latin typeface="Calibri" charset="0"/>
-                        <a:ea typeface="Calibri" charset="0"/>
-                        <a:cs typeface="Calibri" charset="0"/>
-                      </a:endParaRPr>
                     </a:p>
                   </a:txBody>
-                  <a:tcPr>
-                    <a:lnL w="6350" cap="flat" cmpd="sng" algn="ctr">
-                      <a:solidFill>
-                        <a:srgbClr val="CBD5E1"/>
-                      </a:solidFill>
-                      <a:prstDash val="solid"/>
-                      <a:round/>
-                      <a:headEnd type="none" w="med" len="med"/>
-                      <a:tailEnd type="none" w="med" len="med"/>
-                    </a:lnL>
-                    <a:lnR w="6350" cap="flat" cmpd="sng" algn="ctr">
-                      <a:solidFill>
-                        <a:srgbClr val="CBD5E1"/>
-                      </a:solidFill>
-                      <a:prstDash val="solid"/>
-                      <a:round/>
-                      <a:headEnd type="none" w="med" len="med"/>
-                      <a:tailEnd type="none" w="med" len="med"/>
-                    </a:lnR>
-                    <a:lnT w="6350" cap="flat" cmpd="sng" algn="ctr">
-                      <a:solidFill>
-                        <a:srgbClr val="CBD5E1"/>
-                      </a:solidFill>
-                      <a:prstDash val="solid"/>
-                      <a:round/>
-                      <a:headEnd type="none" w="med" len="med"/>
-                      <a:tailEnd type="none" w="med" len="med"/>
-                    </a:lnT>
-                    <a:lnB w="6350" cap="flat" cmpd="sng" algn="ctr">
-                      <a:solidFill>
-                        <a:srgbClr val="CBD5E1"/>
-                      </a:solidFill>
-                      <a:prstDash val="solid"/>
-                      <a:round/>
-                      <a:headEnd type="none" w="med" len="med"/>
-                      <a:tailEnd type="none" w="med" len="med"/>
-                    </a:lnB>
-                  </a:tcPr>
+                  <a:tcPr/>
                 </a:tc>
                 <a:tc>
                   <a:txBody>
                     <a:bodyPr/>
                     <a:lstStyle/>
                     <a:p>
-                      <a:pPr marL="0" indent="0" algn="ctr">
-                        <a:buNone/>
+                      <a:pPr algn="ctr">
+                        <a:defRPr sz="1200"/>
                       </a:pPr>
                       <a:r>
-                        <a:rPr lang="en-US" sz="1100" dirty="0">
-                          <a:solidFill>
-                            <a:srgbClr val="000000"/>
-                          </a:solidFill>
-                          <a:latin typeface="Calibri" pitchFamily="34" charset="0"/>
-                          <a:ea typeface="Calibri" pitchFamily="34" charset="-122"/>
-                          <a:cs typeface="Calibri" pitchFamily="34" charset="-120"/>
-                        </a:rPr>
-                        <a:t>25 kW</a:t>
+                        <a:t>30</a:t>
                       </a:r>
-                      <a:endParaRPr lang="en-US" sz="1100" dirty="0">
-                        <a:latin typeface="Calibri" charset="0"/>
-                        <a:ea typeface="Calibri" charset="0"/>
-                        <a:cs typeface="Calibri" charset="0"/>
-                      </a:endParaRPr>
                     </a:p>
                   </a:txBody>
-                  <a:tcPr>
-                    <a:lnL w="6350" cap="flat" cmpd="sng" algn="ctr">
-                      <a:solidFill>
-                        <a:srgbClr val="CBD5E1"/>
-                      </a:solidFill>
-                      <a:prstDash val="solid"/>
-                      <a:round/>
-                      <a:headEnd type="none" w="med" len="med"/>
-                      <a:tailEnd type="none" w="med" len="med"/>
-                    </a:lnL>
-                    <a:lnR w="6350" cap="flat" cmpd="sng" algn="ctr">
-                      <a:solidFill>
-                        <a:srgbClr val="CBD5E1"/>
-                      </a:solidFill>
-                      <a:prstDash val="solid"/>
-                      <a:round/>
-                      <a:headEnd type="none" w="med" len="med"/>
-                      <a:tailEnd type="none" w="med" len="med"/>
-                    </a:lnR>
-                    <a:lnT w="6350" cap="flat" cmpd="sng" algn="ctr">
-                      <a:solidFill>
-                        <a:srgbClr val="CBD5E1"/>
-                      </a:solidFill>
-                      <a:prstDash val="solid"/>
-                      <a:round/>
-                      <a:headEnd type="none" w="med" len="med"/>
-                      <a:tailEnd type="none" w="med" len="med"/>
-                    </a:lnT>
-                    <a:lnB w="6350" cap="flat" cmpd="sng" algn="ctr">
-                      <a:solidFill>
-                        <a:srgbClr val="CBD5E1"/>
-                      </a:solidFill>
-                      <a:prstDash val="solid"/>
-                      <a:round/>
-                      <a:headEnd type="none" w="med" len="med"/>
-                      <a:tailEnd type="none" w="med" len="med"/>
-                    </a:lnB>
-                  </a:tcPr>
+                  <a:tcPr/>
                 </a:tc>
                 <a:tc>
                   <a:txBody>
                     <a:bodyPr/>
                     <a:lstStyle/>
                     <a:p>
-                      <a:pPr marL="0" indent="0" algn="ctr">
-                        <a:buNone/>
+                      <a:pPr algn="ctr">
+                        <a:defRPr sz="1200"/>
                       </a:pPr>
                       <a:r>
-                        <a:rPr lang="en-US" sz="1100" dirty="0">
-                          <a:solidFill>
-                            <a:srgbClr val="000000"/>
-                          </a:solidFill>
-                          <a:latin typeface="Calibri" pitchFamily="34" charset="0"/>
-                          <a:ea typeface="Calibri" pitchFamily="34" charset="-122"/>
-                          <a:cs typeface="Calibri" pitchFamily="34" charset="-120"/>
-                        </a:rPr>
-                        <a:t>5</a:t>
+                        <a:t>6</a:t>
                       </a:r>
-                      <a:endParaRPr lang="en-US" sz="1100" dirty="0">
-                        <a:latin typeface="Calibri" charset="0"/>
-                        <a:ea typeface="Calibri" charset="0"/>
-                        <a:cs typeface="Calibri" charset="0"/>
-                      </a:endParaRPr>
                     </a:p>
                   </a:txBody>
-                  <a:tcPr>
-                    <a:lnL w="6350" cap="flat" cmpd="sng" algn="ctr">
-                      <a:solidFill>
-                        <a:srgbClr val="CBD5E1"/>
-                      </a:solidFill>
-                      <a:prstDash val="solid"/>
-                      <a:round/>
-                      <a:headEnd type="none" w="med" len="med"/>
-                      <a:tailEnd type="none" w="med" len="med"/>
-                    </a:lnL>
-                    <a:lnR w="6350" cap="flat" cmpd="sng" algn="ctr">
-                      <a:solidFill>
-                        <a:srgbClr val="CBD5E1"/>
-                      </a:solidFill>
-                      <a:prstDash val="solid"/>
-                      <a:round/>
-                      <a:headEnd type="none" w="med" len="med"/>
-                      <a:tailEnd type="none" w="med" len="med"/>
-                    </a:lnR>
-                    <a:lnT w="6350" cap="flat" cmpd="sng" algn="ctr">
-                      <a:solidFill>
-                        <a:srgbClr val="CBD5E1"/>
-                      </a:solidFill>
-                      <a:prstDash val="solid"/>
-                      <a:round/>
-                      <a:headEnd type="none" w="med" len="med"/>
-                      <a:tailEnd type="none" w="med" len="med"/>
-                    </a:lnT>
-                    <a:lnB w="6350" cap="flat" cmpd="sng" algn="ctr">
-                      <a:solidFill>
-                        <a:srgbClr val="CBD5E1"/>
-                      </a:solidFill>
-                      <a:prstDash val="solid"/>
-                      <a:round/>
-                      <a:headEnd type="none" w="med" len="med"/>
-                      <a:tailEnd type="none" w="med" len="med"/>
-                    </a:lnB>
-                  </a:tcPr>
+                  <a:tcPr/>
                 </a:tc>
                 <a:tc>
                   <a:txBody>
                     <a:bodyPr/>
                     <a:lstStyle/>
                     <a:p>
-                      <a:pPr marL="0" indent="0" algn="ctr">
-                        <a:buNone/>
+                      <a:pPr algn="ctr">
+                        <a:defRPr sz="1200"/>
                       </a:pPr>
                       <a:r>
-                        <a:rPr lang="en-US" sz="1100" dirty="0">
-                          <a:solidFill>
-                            <a:srgbClr val="000000"/>
-                          </a:solidFill>
-                          <a:latin typeface="Calibri" pitchFamily="34" charset="0"/>
-                          <a:ea typeface="Calibri" pitchFamily="34" charset="-122"/>
-                          <a:cs typeface="Calibri" pitchFamily="34" charset="-120"/>
-                        </a:rPr>
-                        <a:t>4</a:t>
+                        <a:t>3</a:t>
                       </a:r>
-                      <a:endParaRPr lang="en-US" sz="1100" dirty="0">
-                        <a:latin typeface="Calibri" charset="0"/>
-                        <a:ea typeface="Calibri" charset="0"/>
-                        <a:cs typeface="Calibri" charset="0"/>
-                      </a:endParaRPr>
                     </a:p>
                   </a:txBody>
-                  <a:tcPr>
-                    <a:lnL w="6350" cap="flat" cmpd="sng" algn="ctr">
-                      <a:solidFill>
-                        <a:srgbClr val="CBD5E1"/>
-                      </a:solidFill>
-                      <a:prstDash val="solid"/>
-                      <a:round/>
-                      <a:headEnd type="none" w="med" len="med"/>
-                      <a:tailEnd type="none" w="med" len="med"/>
-                    </a:lnL>
-                    <a:lnR w="6350" cap="flat" cmpd="sng" algn="ctr">
-                      <a:solidFill>
-                        <a:srgbClr val="CBD5E1"/>
-                      </a:solidFill>
-                      <a:prstDash val="solid"/>
-                      <a:round/>
-                      <a:headEnd type="none" w="med" len="med"/>
-                      <a:tailEnd type="none" w="med" len="med"/>
-                    </a:lnR>
-                    <a:lnT w="6350" cap="flat" cmpd="sng" algn="ctr">
-                      <a:solidFill>
-                        <a:srgbClr val="CBD5E1"/>
-                      </a:solidFill>
-                      <a:prstDash val="solid"/>
-                      <a:round/>
-                      <a:headEnd type="none" w="med" len="med"/>
-                      <a:tailEnd type="none" w="med" len="med"/>
-                    </a:lnT>
-                    <a:lnB w="6350" cap="flat" cmpd="sng" algn="ctr">
-                      <a:solidFill>
-                        <a:srgbClr val="CBD5E1"/>
-                      </a:solidFill>
-                      <a:prstDash val="solid"/>
-                      <a:round/>
-                      <a:headEnd type="none" w="med" len="med"/>
-                      <a:tailEnd type="none" w="med" len="med"/>
-                    </a:lnB>
-                  </a:tcPr>
+                  <a:tcPr/>
                 </a:tc>
                 <a:extLst>
                   <a:ext uri="{0D108BD9-81ED-4DB2-BD59-A6C34878D82A}">
@@ -28196,331 +26766,81 @@
                   </a:ext>
                 </a:extLst>
               </a:tr>
-              <a:tr h="320040">
+              <a:tr h="226970">
                 <a:tc>
                   <a:txBody>
                     <a:bodyPr/>
                     <a:lstStyle/>
                     <a:p>
-                      <a:pPr marL="0" indent="0" algn="ctr">
-                        <a:buNone/>
+                      <a:pPr algn="ctr">
+                        <a:defRPr sz="1200"/>
                       </a:pPr>
                       <a:r>
-                        <a:rPr lang="en-US" sz="1100" dirty="0">
-                          <a:solidFill>
-                            <a:srgbClr val="000000"/>
-                          </a:solidFill>
-                          <a:latin typeface="Calibri" pitchFamily="34" charset="0"/>
-                          <a:ea typeface="Calibri" pitchFamily="34" charset="-122"/>
-                          <a:cs typeface="Calibri" pitchFamily="34" charset="-120"/>
-                        </a:rPr>
-                        <a:t>pa_6</a:t>
+                        <a:t>pa_3</a:t>
                       </a:r>
-                      <a:endParaRPr lang="en-US" sz="1100" dirty="0">
-                        <a:latin typeface="Calibri" charset="0"/>
-                        <a:ea typeface="Calibri" charset="0"/>
-                        <a:cs typeface="Calibri" charset="0"/>
-                      </a:endParaRPr>
                     </a:p>
                   </a:txBody>
-                  <a:tcPr>
-                    <a:lnL w="6350" cap="flat" cmpd="sng" algn="ctr">
-                      <a:solidFill>
-                        <a:srgbClr val="CBD5E1"/>
-                      </a:solidFill>
-                      <a:prstDash val="solid"/>
-                      <a:round/>
-                      <a:headEnd type="none" w="med" len="med"/>
-                      <a:tailEnd type="none" w="med" len="med"/>
-                    </a:lnL>
-                    <a:lnR w="6350" cap="flat" cmpd="sng" algn="ctr">
-                      <a:solidFill>
-                        <a:srgbClr val="CBD5E1"/>
-                      </a:solidFill>
-                      <a:prstDash val="solid"/>
-                      <a:round/>
-                      <a:headEnd type="none" w="med" len="med"/>
-                      <a:tailEnd type="none" w="med" len="med"/>
-                    </a:lnR>
-                    <a:lnT w="6350" cap="flat" cmpd="sng" algn="ctr">
-                      <a:solidFill>
-                        <a:srgbClr val="CBD5E1"/>
-                      </a:solidFill>
-                      <a:prstDash val="solid"/>
-                      <a:round/>
-                      <a:headEnd type="none" w="med" len="med"/>
-                      <a:tailEnd type="none" w="med" len="med"/>
-                    </a:lnT>
-                    <a:lnB w="6350" cap="flat" cmpd="sng" algn="ctr">
-                      <a:solidFill>
-                        <a:srgbClr val="CBD5E1"/>
-                      </a:solidFill>
-                      <a:prstDash val="solid"/>
-                      <a:round/>
-                      <a:headEnd type="none" w="med" len="med"/>
-                      <a:tailEnd type="none" w="med" len="med"/>
-                    </a:lnB>
-                  </a:tcPr>
+                  <a:tcPr/>
                 </a:tc>
                 <a:tc>
                   <a:txBody>
                     <a:bodyPr/>
                     <a:lstStyle/>
                     <a:p>
-                      <a:pPr marL="0" indent="0" algn="ctr">
-                        <a:buNone/>
+                      <a:pPr algn="ctr">
+                        <a:defRPr sz="1200"/>
                       </a:pPr>
                       <a:r>
-                        <a:rPr lang="en-US" sz="1100" dirty="0">
-                          <a:solidFill>
-                            <a:srgbClr val="000000"/>
-                          </a:solidFill>
-                          <a:latin typeface="Calibri" pitchFamily="34" charset="0"/>
-                          <a:ea typeface="Calibri" pitchFamily="34" charset="-122"/>
-                          <a:cs typeface="Calibri" pitchFamily="34" charset="-120"/>
-                        </a:rPr>
-                        <a:t>E5</a:t>
+                        <a:t>E1</a:t>
                       </a:r>
-                      <a:endParaRPr lang="en-US" sz="1100" dirty="0">
-                        <a:latin typeface="Calibri" charset="0"/>
-                        <a:ea typeface="Calibri" charset="0"/>
-                        <a:cs typeface="Calibri" charset="0"/>
-                      </a:endParaRPr>
                     </a:p>
                   </a:txBody>
-                  <a:tcPr>
-                    <a:lnL w="6350" cap="flat" cmpd="sng" algn="ctr">
-                      <a:solidFill>
-                        <a:srgbClr val="CBD5E1"/>
-                      </a:solidFill>
-                      <a:prstDash val="solid"/>
-                      <a:round/>
-                      <a:headEnd type="none" w="med" len="med"/>
-                      <a:tailEnd type="none" w="med" len="med"/>
-                    </a:lnL>
-                    <a:lnR w="6350" cap="flat" cmpd="sng" algn="ctr">
-                      <a:solidFill>
-                        <a:srgbClr val="CBD5E1"/>
-                      </a:solidFill>
-                      <a:prstDash val="solid"/>
-                      <a:round/>
-                      <a:headEnd type="none" w="med" len="med"/>
-                      <a:tailEnd type="none" w="med" len="med"/>
-                    </a:lnR>
-                    <a:lnT w="6350" cap="flat" cmpd="sng" algn="ctr">
-                      <a:solidFill>
-                        <a:srgbClr val="CBD5E1"/>
-                      </a:solidFill>
-                      <a:prstDash val="solid"/>
-                      <a:round/>
-                      <a:headEnd type="none" w="med" len="med"/>
-                      <a:tailEnd type="none" w="med" len="med"/>
-                    </a:lnT>
-                    <a:lnB w="6350" cap="flat" cmpd="sng" algn="ctr">
-                      <a:solidFill>
-                        <a:srgbClr val="CBD5E1"/>
-                      </a:solidFill>
-                      <a:prstDash val="solid"/>
-                      <a:round/>
-                      <a:headEnd type="none" w="med" len="med"/>
-                      <a:tailEnd type="none" w="med" len="med"/>
-                    </a:lnB>
-                  </a:tcPr>
+                  <a:tcPr/>
                 </a:tc>
                 <a:tc>
                   <a:txBody>
                     <a:bodyPr/>
                     <a:lstStyle/>
                     <a:p>
-                      <a:pPr marL="0" indent="0" algn="ctr">
-                        <a:buNone/>
+                      <a:pPr algn="ctr">
+                        <a:defRPr sz="1200"/>
                       </a:pPr>
                       <a:r>
-                        <a:rPr lang="en-US" sz="1100" dirty="0">
-                          <a:solidFill>
-                            <a:srgbClr val="000000"/>
-                          </a:solidFill>
-                          <a:latin typeface="Calibri" pitchFamily="34" charset="0"/>
-                          <a:ea typeface="Calibri" pitchFamily="34" charset="-122"/>
-                          <a:cs typeface="Calibri" pitchFamily="34" charset="-120"/>
-                        </a:rPr>
-                        <a:t>30 kW</a:t>
+                        <a:t>25</a:t>
                       </a:r>
-                      <a:endParaRPr lang="en-US" sz="1100" dirty="0">
-                        <a:latin typeface="Calibri" charset="0"/>
-                        <a:ea typeface="Calibri" charset="0"/>
-                        <a:cs typeface="Calibri" charset="0"/>
-                      </a:endParaRPr>
                     </a:p>
                   </a:txBody>
-                  <a:tcPr>
-                    <a:lnL w="6350" cap="flat" cmpd="sng" algn="ctr">
-                      <a:solidFill>
-                        <a:srgbClr val="CBD5E1"/>
-                      </a:solidFill>
-                      <a:prstDash val="solid"/>
-                      <a:round/>
-                      <a:headEnd type="none" w="med" len="med"/>
-                      <a:tailEnd type="none" w="med" len="med"/>
-                    </a:lnL>
-                    <a:lnR w="6350" cap="flat" cmpd="sng" algn="ctr">
-                      <a:solidFill>
-                        <a:srgbClr val="CBD5E1"/>
-                      </a:solidFill>
-                      <a:prstDash val="solid"/>
-                      <a:round/>
-                      <a:headEnd type="none" w="med" len="med"/>
-                      <a:tailEnd type="none" w="med" len="med"/>
-                    </a:lnR>
-                    <a:lnT w="6350" cap="flat" cmpd="sng" algn="ctr">
-                      <a:solidFill>
-                        <a:srgbClr val="CBD5E1"/>
-                      </a:solidFill>
-                      <a:prstDash val="solid"/>
-                      <a:round/>
-                      <a:headEnd type="none" w="med" len="med"/>
-                      <a:tailEnd type="none" w="med" len="med"/>
-                    </a:lnT>
-                    <a:lnB w="6350" cap="flat" cmpd="sng" algn="ctr">
-                      <a:solidFill>
-                        <a:srgbClr val="CBD5E1"/>
-                      </a:solidFill>
-                      <a:prstDash val="solid"/>
-                      <a:round/>
-                      <a:headEnd type="none" w="med" len="med"/>
-                      <a:tailEnd type="none" w="med" len="med"/>
-                    </a:lnB>
-                  </a:tcPr>
+                  <a:tcPr/>
                 </a:tc>
                 <a:tc>
                   <a:txBody>
                     <a:bodyPr/>
                     <a:lstStyle/>
                     <a:p>
-                      <a:pPr marL="0" indent="0" algn="ctr">
-                        <a:buNone/>
+                      <a:pPr algn="ctr">
+                        <a:defRPr sz="1200"/>
                       </a:pPr>
                       <a:r>
-                        <a:rPr lang="en-US" sz="1100" dirty="0">
-                          <a:solidFill>
-                            <a:srgbClr val="000000"/>
-                          </a:solidFill>
-                          <a:latin typeface="Calibri" pitchFamily="34" charset="0"/>
-                          <a:ea typeface="Calibri" pitchFamily="34" charset="-122"/>
-                          <a:cs typeface="Calibri" pitchFamily="34" charset="-120"/>
-                        </a:rPr>
-                        <a:t>6</a:t>
+                        <a:t>5</a:t>
                       </a:r>
-                      <a:endParaRPr lang="en-US" sz="1100" dirty="0">
-                        <a:latin typeface="Calibri" charset="0"/>
-                        <a:ea typeface="Calibri" charset="0"/>
-                        <a:cs typeface="Calibri" charset="0"/>
-                      </a:endParaRPr>
                     </a:p>
                   </a:txBody>
-                  <a:tcPr>
-                    <a:lnL w="6350" cap="flat" cmpd="sng" algn="ctr">
-                      <a:solidFill>
-                        <a:srgbClr val="CBD5E1"/>
-                      </a:solidFill>
-                      <a:prstDash val="solid"/>
-                      <a:round/>
-                      <a:headEnd type="none" w="med" len="med"/>
-                      <a:tailEnd type="none" w="med" len="med"/>
-                    </a:lnL>
-                    <a:lnR w="6350" cap="flat" cmpd="sng" algn="ctr">
-                      <a:solidFill>
-                        <a:srgbClr val="CBD5E1"/>
-                      </a:solidFill>
-                      <a:prstDash val="solid"/>
-                      <a:round/>
-                      <a:headEnd type="none" w="med" len="med"/>
-                      <a:tailEnd type="none" w="med" len="med"/>
-                    </a:lnR>
-                    <a:lnT w="6350" cap="flat" cmpd="sng" algn="ctr">
-                      <a:solidFill>
-                        <a:srgbClr val="CBD5E1"/>
-                      </a:solidFill>
-                      <a:prstDash val="solid"/>
-                      <a:round/>
-                      <a:headEnd type="none" w="med" len="med"/>
-                      <a:tailEnd type="none" w="med" len="med"/>
-                    </a:lnT>
-                    <a:lnB w="6350" cap="flat" cmpd="sng" algn="ctr">
-                      <a:solidFill>
-                        <a:srgbClr val="CBD5E1"/>
-                      </a:solidFill>
-                      <a:prstDash val="solid"/>
-                      <a:round/>
-                      <a:headEnd type="none" w="med" len="med"/>
-                      <a:tailEnd type="none" w="med" len="med"/>
-                    </a:lnB>
-                  </a:tcPr>
+                  <a:tcPr/>
                 </a:tc>
                 <a:tc>
                   <a:txBody>
                     <a:bodyPr/>
                     <a:lstStyle/>
                     <a:p>
-                      <a:pPr marL="0" indent="0" algn="ctr">
-                        <a:buNone/>
+                      <a:pPr algn="ctr">
+                        <a:defRPr sz="1200"/>
                       </a:pPr>
                       <a:r>
-                        <a:rPr lang="en-US" sz="1100" dirty="0">
-                          <a:solidFill>
-                            <a:srgbClr val="000000"/>
-                          </a:solidFill>
-                          <a:latin typeface="Calibri" pitchFamily="34" charset="0"/>
-                          <a:ea typeface="Calibri" pitchFamily="34" charset="-122"/>
-                          <a:cs typeface="Calibri" pitchFamily="34" charset="-120"/>
-                        </a:rPr>
-                        <a:t>6</a:t>
+                        <a:t>4</a:t>
                       </a:r>
-                      <a:endParaRPr lang="en-US" sz="1100" dirty="0">
-                        <a:latin typeface="Calibri" charset="0"/>
-                        <a:ea typeface="Calibri" charset="0"/>
-                        <a:cs typeface="Calibri" charset="0"/>
-                      </a:endParaRPr>
                     </a:p>
                   </a:txBody>
-                  <a:tcPr>
-                    <a:lnL w="6350" cap="flat" cmpd="sng" algn="ctr">
-                      <a:solidFill>
-                        <a:srgbClr val="CBD5E1"/>
-                      </a:solidFill>
-                      <a:prstDash val="solid"/>
-                      <a:round/>
-                      <a:headEnd type="none" w="med" len="med"/>
-                      <a:tailEnd type="none" w="med" len="med"/>
-                    </a:lnL>
-                    <a:lnR w="6350" cap="flat" cmpd="sng" algn="ctr">
-                      <a:solidFill>
-                        <a:srgbClr val="CBD5E1"/>
-                      </a:solidFill>
-                      <a:prstDash val="solid"/>
-                      <a:round/>
-                      <a:headEnd type="none" w="med" len="med"/>
-                      <a:tailEnd type="none" w="med" len="med"/>
-                    </a:lnR>
-                    <a:lnT w="6350" cap="flat" cmpd="sng" algn="ctr">
-                      <a:solidFill>
-                        <a:srgbClr val="CBD5E1"/>
-                      </a:solidFill>
-                      <a:prstDash val="solid"/>
-                      <a:round/>
-                      <a:headEnd type="none" w="med" len="med"/>
-                      <a:tailEnd type="none" w="med" len="med"/>
-                    </a:lnT>
-                    <a:lnB w="6350" cap="flat" cmpd="sng" algn="ctr">
-                      <a:solidFill>
-                        <a:srgbClr val="CBD5E1"/>
-                      </a:solidFill>
-                      <a:prstDash val="solid"/>
-                      <a:round/>
-                      <a:headEnd type="none" w="med" len="med"/>
-                      <a:tailEnd type="none" w="med" len="med"/>
-                    </a:lnB>
-                  </a:tcPr>
+                  <a:tcPr/>
                 </a:tc>
                 <a:extLst>
                   <a:ext uri="{0D108BD9-81ED-4DB2-BD59-A6C34878D82A}">
@@ -28528,331 +26848,81 @@
                   </a:ext>
                 </a:extLst>
               </a:tr>
-              <a:tr h="320040">
+              <a:tr h="226970">
                 <a:tc>
                   <a:txBody>
                     <a:bodyPr/>
                     <a:lstStyle/>
                     <a:p>
-                      <a:pPr marL="0" indent="0" algn="ctr">
-                        <a:buNone/>
+                      <a:pPr algn="ctr">
+                        <a:defRPr sz="1200"/>
                       </a:pPr>
                       <a:r>
-                        <a:rPr lang="en-US" sz="1100" dirty="0">
-                          <a:solidFill>
-                            <a:srgbClr val="000000"/>
-                          </a:solidFill>
-                          <a:latin typeface="Calibri" pitchFamily="34" charset="0"/>
-                          <a:ea typeface="Calibri" pitchFamily="34" charset="-122"/>
-                          <a:cs typeface="Calibri" pitchFamily="34" charset="-120"/>
-                        </a:rPr>
-                        <a:t>pa_7</a:t>
+                        <a:t>pa_3_rev</a:t>
                       </a:r>
-                      <a:endParaRPr lang="en-US" sz="1100" dirty="0">
-                        <a:latin typeface="Calibri" charset="0"/>
-                        <a:ea typeface="Calibri" charset="0"/>
-                        <a:cs typeface="Calibri" charset="0"/>
-                      </a:endParaRPr>
                     </a:p>
                   </a:txBody>
-                  <a:tcPr>
-                    <a:lnL w="6350" cap="flat" cmpd="sng" algn="ctr">
-                      <a:solidFill>
-                        <a:srgbClr val="CBD5E1"/>
-                      </a:solidFill>
-                      <a:prstDash val="solid"/>
-                      <a:round/>
-                      <a:headEnd type="none" w="med" len="med"/>
-                      <a:tailEnd type="none" w="med" len="med"/>
-                    </a:lnL>
-                    <a:lnR w="6350" cap="flat" cmpd="sng" algn="ctr">
-                      <a:solidFill>
-                        <a:srgbClr val="CBD5E1"/>
-                      </a:solidFill>
-                      <a:prstDash val="solid"/>
-                      <a:round/>
-                      <a:headEnd type="none" w="med" len="med"/>
-                      <a:tailEnd type="none" w="med" len="med"/>
-                    </a:lnR>
-                    <a:lnT w="6350" cap="flat" cmpd="sng" algn="ctr">
-                      <a:solidFill>
-                        <a:srgbClr val="CBD5E1"/>
-                      </a:solidFill>
-                      <a:prstDash val="solid"/>
-                      <a:round/>
-                      <a:headEnd type="none" w="med" len="med"/>
-                      <a:tailEnd type="none" w="med" len="med"/>
-                    </a:lnT>
-                    <a:lnB w="6350" cap="flat" cmpd="sng" algn="ctr">
-                      <a:solidFill>
-                        <a:srgbClr val="CBD5E1"/>
-                      </a:solidFill>
-                      <a:prstDash val="solid"/>
-                      <a:round/>
-                      <a:headEnd type="none" w="med" len="med"/>
-                      <a:tailEnd type="none" w="med" len="med"/>
-                    </a:lnB>
-                  </a:tcPr>
+                  <a:tcPr/>
                 </a:tc>
                 <a:tc>
                   <a:txBody>
                     <a:bodyPr/>
                     <a:lstStyle/>
                     <a:p>
-                      <a:pPr marL="0" indent="0" algn="ctr">
-                        <a:buNone/>
+                      <a:pPr algn="ctr">
+                        <a:defRPr sz="1200"/>
                       </a:pPr>
                       <a:r>
-                        <a:rPr lang="en-US" sz="1100" dirty="0">
-                          <a:solidFill>
-                            <a:srgbClr val="000000"/>
-                          </a:solidFill>
-                          <a:latin typeface="Calibri" pitchFamily="34" charset="0"/>
-                          <a:ea typeface="Calibri" pitchFamily="34" charset="-122"/>
-                          <a:cs typeface="Calibri" pitchFamily="34" charset="-120"/>
-                        </a:rPr>
-                        <a:t>E6</a:t>
+                        <a:t>-E1</a:t>
                       </a:r>
-                      <a:endParaRPr lang="en-US" sz="1100" dirty="0">
-                        <a:latin typeface="Calibri" charset="0"/>
-                        <a:ea typeface="Calibri" charset="0"/>
-                        <a:cs typeface="Calibri" charset="0"/>
-                      </a:endParaRPr>
                     </a:p>
                   </a:txBody>
-                  <a:tcPr>
-                    <a:lnL w="6350" cap="flat" cmpd="sng" algn="ctr">
-                      <a:solidFill>
-                        <a:srgbClr val="CBD5E1"/>
-                      </a:solidFill>
-                      <a:prstDash val="solid"/>
-                      <a:round/>
-                      <a:headEnd type="none" w="med" len="med"/>
-                      <a:tailEnd type="none" w="med" len="med"/>
-                    </a:lnL>
-                    <a:lnR w="6350" cap="flat" cmpd="sng" algn="ctr">
-                      <a:solidFill>
-                        <a:srgbClr val="CBD5E1"/>
-                      </a:solidFill>
-                      <a:prstDash val="solid"/>
-                      <a:round/>
-                      <a:headEnd type="none" w="med" len="med"/>
-                      <a:tailEnd type="none" w="med" len="med"/>
-                    </a:lnR>
-                    <a:lnT w="6350" cap="flat" cmpd="sng" algn="ctr">
-                      <a:solidFill>
-                        <a:srgbClr val="CBD5E1"/>
-                      </a:solidFill>
-                      <a:prstDash val="solid"/>
-                      <a:round/>
-                      <a:headEnd type="none" w="med" len="med"/>
-                      <a:tailEnd type="none" w="med" len="med"/>
-                    </a:lnT>
-                    <a:lnB w="6350" cap="flat" cmpd="sng" algn="ctr">
-                      <a:solidFill>
-                        <a:srgbClr val="CBD5E1"/>
-                      </a:solidFill>
-                      <a:prstDash val="solid"/>
-                      <a:round/>
-                      <a:headEnd type="none" w="med" len="med"/>
-                      <a:tailEnd type="none" w="med" len="med"/>
-                    </a:lnB>
-                  </a:tcPr>
+                  <a:tcPr/>
                 </a:tc>
                 <a:tc>
                   <a:txBody>
                     <a:bodyPr/>
                     <a:lstStyle/>
                     <a:p>
-                      <a:pPr marL="0" indent="0" algn="ctr">
-                        <a:buNone/>
+                      <a:pPr algn="ctr">
+                        <a:defRPr sz="1200"/>
                       </a:pPr>
                       <a:r>
-                        <a:rPr lang="en-US" sz="1100" dirty="0">
-                          <a:solidFill>
-                            <a:srgbClr val="000000"/>
-                          </a:solidFill>
-                          <a:latin typeface="Calibri" pitchFamily="34" charset="0"/>
-                          <a:ea typeface="Calibri" pitchFamily="34" charset="-122"/>
-                          <a:cs typeface="Calibri" pitchFamily="34" charset="-120"/>
-                        </a:rPr>
-                        <a:t>30 kW</a:t>
+                        <a:t>30</a:t>
                       </a:r>
-                      <a:endParaRPr lang="en-US" sz="1100" dirty="0">
-                        <a:latin typeface="Calibri" charset="0"/>
-                        <a:ea typeface="Calibri" charset="0"/>
-                        <a:cs typeface="Calibri" charset="0"/>
-                      </a:endParaRPr>
                     </a:p>
                   </a:txBody>
-                  <a:tcPr>
-                    <a:lnL w="6350" cap="flat" cmpd="sng" algn="ctr">
-                      <a:solidFill>
-                        <a:srgbClr val="CBD5E1"/>
-                      </a:solidFill>
-                      <a:prstDash val="solid"/>
-                      <a:round/>
-                      <a:headEnd type="none" w="med" len="med"/>
-                      <a:tailEnd type="none" w="med" len="med"/>
-                    </a:lnL>
-                    <a:lnR w="6350" cap="flat" cmpd="sng" algn="ctr">
-                      <a:solidFill>
-                        <a:srgbClr val="CBD5E1"/>
-                      </a:solidFill>
-                      <a:prstDash val="solid"/>
-                      <a:round/>
-                      <a:headEnd type="none" w="med" len="med"/>
-                      <a:tailEnd type="none" w="med" len="med"/>
-                    </a:lnR>
-                    <a:lnT w="6350" cap="flat" cmpd="sng" algn="ctr">
-                      <a:solidFill>
-                        <a:srgbClr val="CBD5E1"/>
-                      </a:solidFill>
-                      <a:prstDash val="solid"/>
-                      <a:round/>
-                      <a:headEnd type="none" w="med" len="med"/>
-                      <a:tailEnd type="none" w="med" len="med"/>
-                    </a:lnT>
-                    <a:lnB w="6350" cap="flat" cmpd="sng" algn="ctr">
-                      <a:solidFill>
-                        <a:srgbClr val="CBD5E1"/>
-                      </a:solidFill>
-                      <a:prstDash val="solid"/>
-                      <a:round/>
-                      <a:headEnd type="none" w="med" len="med"/>
-                      <a:tailEnd type="none" w="med" len="med"/>
-                    </a:lnB>
-                  </a:tcPr>
+                  <a:tcPr/>
                 </a:tc>
                 <a:tc>
                   <a:txBody>
                     <a:bodyPr/>
                     <a:lstStyle/>
                     <a:p>
-                      <a:pPr marL="0" indent="0" algn="ctr">
-                        <a:buNone/>
+                      <a:pPr algn="ctr">
+                        <a:defRPr sz="1200"/>
                       </a:pPr>
                       <a:r>
-                        <a:rPr lang="en-US" sz="1100" dirty="0">
-                          <a:solidFill>
-                            <a:srgbClr val="000000"/>
-                          </a:solidFill>
-                          <a:latin typeface="Calibri" pitchFamily="34" charset="0"/>
-                          <a:ea typeface="Calibri" pitchFamily="34" charset="-122"/>
-                          <a:cs typeface="Calibri" pitchFamily="34" charset="-120"/>
-                        </a:rPr>
                         <a:t>6</a:t>
                       </a:r>
-                      <a:endParaRPr lang="en-US" sz="1100" dirty="0">
-                        <a:latin typeface="Calibri" charset="0"/>
-                        <a:ea typeface="Calibri" charset="0"/>
-                        <a:cs typeface="Calibri" charset="0"/>
-                      </a:endParaRPr>
                     </a:p>
                   </a:txBody>
-                  <a:tcPr>
-                    <a:lnL w="6350" cap="flat" cmpd="sng" algn="ctr">
-                      <a:solidFill>
-                        <a:srgbClr val="CBD5E1"/>
-                      </a:solidFill>
-                      <a:prstDash val="solid"/>
-                      <a:round/>
-                      <a:headEnd type="none" w="med" len="med"/>
-                      <a:tailEnd type="none" w="med" len="med"/>
-                    </a:lnL>
-                    <a:lnR w="6350" cap="flat" cmpd="sng" algn="ctr">
-                      <a:solidFill>
-                        <a:srgbClr val="CBD5E1"/>
-                      </a:solidFill>
-                      <a:prstDash val="solid"/>
-                      <a:round/>
-                      <a:headEnd type="none" w="med" len="med"/>
-                      <a:tailEnd type="none" w="med" len="med"/>
-                    </a:lnR>
-                    <a:lnT w="6350" cap="flat" cmpd="sng" algn="ctr">
-                      <a:solidFill>
-                        <a:srgbClr val="CBD5E1"/>
-                      </a:solidFill>
-                      <a:prstDash val="solid"/>
-                      <a:round/>
-                      <a:headEnd type="none" w="med" len="med"/>
-                      <a:tailEnd type="none" w="med" len="med"/>
-                    </a:lnT>
-                    <a:lnB w="6350" cap="flat" cmpd="sng" algn="ctr">
-                      <a:solidFill>
-                        <a:srgbClr val="CBD5E1"/>
-                      </a:solidFill>
-                      <a:prstDash val="solid"/>
-                      <a:round/>
-                      <a:headEnd type="none" w="med" len="med"/>
-                      <a:tailEnd type="none" w="med" len="med"/>
-                    </a:lnB>
-                  </a:tcPr>
+                  <a:tcPr/>
                 </a:tc>
                 <a:tc>
                   <a:txBody>
                     <a:bodyPr/>
                     <a:lstStyle/>
                     <a:p>
-                      <a:pPr marL="0" indent="0" algn="ctr">
-                        <a:buNone/>
+                      <a:pPr algn="ctr">
+                        <a:defRPr sz="1200"/>
                       </a:pPr>
                       <a:r>
-                        <a:rPr lang="en-US" sz="1100" dirty="0">
-                          <a:solidFill>
-                            <a:srgbClr val="000000"/>
-                          </a:solidFill>
-                          <a:latin typeface="Calibri" pitchFamily="34" charset="0"/>
-                          <a:ea typeface="Calibri" pitchFamily="34" charset="-122"/>
-                          <a:cs typeface="Calibri" pitchFamily="34" charset="-120"/>
-                        </a:rPr>
                         <a:t>6</a:t>
                       </a:r>
-                      <a:endParaRPr lang="en-US" sz="1100" dirty="0">
-                        <a:latin typeface="Calibri" charset="0"/>
-                        <a:ea typeface="Calibri" charset="0"/>
-                        <a:cs typeface="Calibri" charset="0"/>
-                      </a:endParaRPr>
                     </a:p>
                   </a:txBody>
-                  <a:tcPr>
-                    <a:lnL w="6350" cap="flat" cmpd="sng" algn="ctr">
-                      <a:solidFill>
-                        <a:srgbClr val="CBD5E1"/>
-                      </a:solidFill>
-                      <a:prstDash val="solid"/>
-                      <a:round/>
-                      <a:headEnd type="none" w="med" len="med"/>
-                      <a:tailEnd type="none" w="med" len="med"/>
-                    </a:lnL>
-                    <a:lnR w="6350" cap="flat" cmpd="sng" algn="ctr">
-                      <a:solidFill>
-                        <a:srgbClr val="CBD5E1"/>
-                      </a:solidFill>
-                      <a:prstDash val="solid"/>
-                      <a:round/>
-                      <a:headEnd type="none" w="med" len="med"/>
-                      <a:tailEnd type="none" w="med" len="med"/>
-                    </a:lnR>
-                    <a:lnT w="6350" cap="flat" cmpd="sng" algn="ctr">
-                      <a:solidFill>
-                        <a:srgbClr val="CBD5E1"/>
-                      </a:solidFill>
-                      <a:prstDash val="solid"/>
-                      <a:round/>
-                      <a:headEnd type="none" w="med" len="med"/>
-                      <a:tailEnd type="none" w="med" len="med"/>
-                    </a:lnT>
-                    <a:lnB w="6350" cap="flat" cmpd="sng" algn="ctr">
-                      <a:solidFill>
-                        <a:srgbClr val="CBD5E1"/>
-                      </a:solidFill>
-                      <a:prstDash val="solid"/>
-                      <a:round/>
-                      <a:headEnd type="none" w="med" len="med"/>
-                      <a:tailEnd type="none" w="med" len="med"/>
-                    </a:lnB>
-                  </a:tcPr>
+                  <a:tcPr/>
                 </a:tc>
                 <a:extLst>
                   <a:ext uri="{0D108BD9-81ED-4DB2-BD59-A6C34878D82A}">
@@ -28860,331 +26930,82 @@
                   </a:ext>
                 </a:extLst>
               </a:tr>
-              <a:tr h="320040">
+              <a:tr h="226970">
                 <a:tc>
                   <a:txBody>
                     <a:bodyPr/>
                     <a:lstStyle/>
                     <a:p>
-                      <a:pPr marL="0" indent="0" algn="ctr">
-                        <a:buNone/>
+                      <a:pPr algn="ctr">
+                        <a:defRPr sz="1200"/>
                       </a:pPr>
                       <a:r>
-                        <a:rPr lang="en-US" sz="1100" dirty="0">
-                          <a:solidFill>
-                            <a:srgbClr val="000000"/>
-                          </a:solidFill>
-                          <a:latin typeface="Calibri" pitchFamily="34" charset="0"/>
-                          <a:ea typeface="Calibri" pitchFamily="34" charset="-122"/>
-                          <a:cs typeface="Calibri" pitchFamily="34" charset="-120"/>
-                        </a:rPr>
-                        <a:t>pa_8_rev</a:t>
+                        <a:rPr dirty="0"/>
+                        <a:t>pa_6</a:t>
                       </a:r>
-                      <a:endParaRPr lang="en-US" sz="1100" dirty="0">
-                        <a:latin typeface="Calibri" charset="0"/>
-                        <a:ea typeface="Calibri" charset="0"/>
-                        <a:cs typeface="Calibri" charset="0"/>
-                      </a:endParaRPr>
                     </a:p>
                   </a:txBody>
-                  <a:tcPr>
-                    <a:lnL w="6350" cap="flat" cmpd="sng" algn="ctr">
-                      <a:solidFill>
-                        <a:srgbClr val="CBD5E1"/>
-                      </a:solidFill>
-                      <a:prstDash val="solid"/>
-                      <a:round/>
-                      <a:headEnd type="none" w="med" len="med"/>
-                      <a:tailEnd type="none" w="med" len="med"/>
-                    </a:lnL>
-                    <a:lnR w="6350" cap="flat" cmpd="sng" algn="ctr">
-                      <a:solidFill>
-                        <a:srgbClr val="CBD5E1"/>
-                      </a:solidFill>
-                      <a:prstDash val="solid"/>
-                      <a:round/>
-                      <a:headEnd type="none" w="med" len="med"/>
-                      <a:tailEnd type="none" w="med" len="med"/>
-                    </a:lnR>
-                    <a:lnT w="6350" cap="flat" cmpd="sng" algn="ctr">
-                      <a:solidFill>
-                        <a:srgbClr val="CBD5E1"/>
-                      </a:solidFill>
-                      <a:prstDash val="solid"/>
-                      <a:round/>
-                      <a:headEnd type="none" w="med" len="med"/>
-                      <a:tailEnd type="none" w="med" len="med"/>
-                    </a:lnT>
-                    <a:lnB w="6350" cap="flat" cmpd="sng" algn="ctr">
-                      <a:solidFill>
-                        <a:srgbClr val="CBD5E1"/>
-                      </a:solidFill>
-                      <a:prstDash val="solid"/>
-                      <a:round/>
-                      <a:headEnd type="none" w="med" len="med"/>
-                      <a:tailEnd type="none" w="med" len="med"/>
-                    </a:lnB>
-                  </a:tcPr>
+                  <a:tcPr/>
                 </a:tc>
                 <a:tc>
                   <a:txBody>
                     <a:bodyPr/>
                     <a:lstStyle/>
                     <a:p>
-                      <a:pPr marL="0" indent="0" algn="ctr">
-                        <a:buNone/>
+                      <a:pPr algn="ctr">
+                        <a:defRPr sz="1200"/>
                       </a:pPr>
                       <a:r>
-                        <a:rPr lang="en-US" sz="1100" dirty="0">
-                          <a:solidFill>
-                            <a:srgbClr val="000000"/>
-                          </a:solidFill>
-                          <a:latin typeface="Calibri" pitchFamily="34" charset="0"/>
-                          <a:ea typeface="Calibri" pitchFamily="34" charset="-122"/>
-                          <a:cs typeface="Calibri" pitchFamily="34" charset="-120"/>
-                        </a:rPr>
-                        <a:t>-E7</a:t>
+                        <a:t>E5</a:t>
                       </a:r>
-                      <a:endParaRPr lang="en-US" sz="1100" dirty="0">
-                        <a:latin typeface="Calibri" charset="0"/>
-                        <a:ea typeface="Calibri" charset="0"/>
-                        <a:cs typeface="Calibri" charset="0"/>
-                      </a:endParaRPr>
                     </a:p>
                   </a:txBody>
-                  <a:tcPr>
-                    <a:lnL w="6350" cap="flat" cmpd="sng" algn="ctr">
-                      <a:solidFill>
-                        <a:srgbClr val="CBD5E1"/>
-                      </a:solidFill>
-                      <a:prstDash val="solid"/>
-                      <a:round/>
-                      <a:headEnd type="none" w="med" len="med"/>
-                      <a:tailEnd type="none" w="med" len="med"/>
-                    </a:lnL>
-                    <a:lnR w="6350" cap="flat" cmpd="sng" algn="ctr">
-                      <a:solidFill>
-                        <a:srgbClr val="CBD5E1"/>
-                      </a:solidFill>
-                      <a:prstDash val="solid"/>
-                      <a:round/>
-                      <a:headEnd type="none" w="med" len="med"/>
-                      <a:tailEnd type="none" w="med" len="med"/>
-                    </a:lnR>
-                    <a:lnT w="6350" cap="flat" cmpd="sng" algn="ctr">
-                      <a:solidFill>
-                        <a:srgbClr val="CBD5E1"/>
-                      </a:solidFill>
-                      <a:prstDash val="solid"/>
-                      <a:round/>
-                      <a:headEnd type="none" w="med" len="med"/>
-                      <a:tailEnd type="none" w="med" len="med"/>
-                    </a:lnT>
-                    <a:lnB w="6350" cap="flat" cmpd="sng" algn="ctr">
-                      <a:solidFill>
-                        <a:srgbClr val="CBD5E1"/>
-                      </a:solidFill>
-                      <a:prstDash val="solid"/>
-                      <a:round/>
-                      <a:headEnd type="none" w="med" len="med"/>
-                      <a:tailEnd type="none" w="med" len="med"/>
-                    </a:lnB>
-                  </a:tcPr>
+                  <a:tcPr/>
                 </a:tc>
                 <a:tc>
                   <a:txBody>
                     <a:bodyPr/>
                     <a:lstStyle/>
                     <a:p>
-                      <a:pPr marL="0" indent="0" algn="ctr">
-                        <a:buNone/>
+                      <a:pPr algn="ctr">
+                        <a:defRPr sz="1200"/>
                       </a:pPr>
                       <a:r>
-                        <a:rPr lang="en-US" sz="1100" dirty="0">
-                          <a:solidFill>
-                            <a:srgbClr val="000000"/>
-                          </a:solidFill>
-                          <a:latin typeface="Calibri" pitchFamily="34" charset="0"/>
-                          <a:ea typeface="Calibri" pitchFamily="34" charset="-122"/>
-                          <a:cs typeface="Calibri" pitchFamily="34" charset="-120"/>
-                        </a:rPr>
-                        <a:t>50 kW</a:t>
+                        <a:t>30</a:t>
                       </a:r>
-                      <a:endParaRPr lang="en-US" sz="1100" dirty="0">
-                        <a:latin typeface="Calibri" charset="0"/>
-                        <a:ea typeface="Calibri" charset="0"/>
-                        <a:cs typeface="Calibri" charset="0"/>
-                      </a:endParaRPr>
                     </a:p>
                   </a:txBody>
-                  <a:tcPr>
-                    <a:lnL w="6350" cap="flat" cmpd="sng" algn="ctr">
-                      <a:solidFill>
-                        <a:srgbClr val="CBD5E1"/>
-                      </a:solidFill>
-                      <a:prstDash val="solid"/>
-                      <a:round/>
-                      <a:headEnd type="none" w="med" len="med"/>
-                      <a:tailEnd type="none" w="med" len="med"/>
-                    </a:lnL>
-                    <a:lnR w="6350" cap="flat" cmpd="sng" algn="ctr">
-                      <a:solidFill>
-                        <a:srgbClr val="CBD5E1"/>
-                      </a:solidFill>
-                      <a:prstDash val="solid"/>
-                      <a:round/>
-                      <a:headEnd type="none" w="med" len="med"/>
-                      <a:tailEnd type="none" w="med" len="med"/>
-                    </a:lnR>
-                    <a:lnT w="6350" cap="flat" cmpd="sng" algn="ctr">
-                      <a:solidFill>
-                        <a:srgbClr val="CBD5E1"/>
-                      </a:solidFill>
-                      <a:prstDash val="solid"/>
-                      <a:round/>
-                      <a:headEnd type="none" w="med" len="med"/>
-                      <a:tailEnd type="none" w="med" len="med"/>
-                    </a:lnT>
-                    <a:lnB w="6350" cap="flat" cmpd="sng" algn="ctr">
-                      <a:solidFill>
-                        <a:srgbClr val="CBD5E1"/>
-                      </a:solidFill>
-                      <a:prstDash val="solid"/>
-                      <a:round/>
-                      <a:headEnd type="none" w="med" len="med"/>
-                      <a:tailEnd type="none" w="med" len="med"/>
-                    </a:lnB>
-                  </a:tcPr>
+                  <a:tcPr/>
                 </a:tc>
                 <a:tc>
                   <a:txBody>
                     <a:bodyPr/>
                     <a:lstStyle/>
                     <a:p>
-                      <a:pPr marL="0" indent="0" algn="ctr">
-                        <a:buNone/>
+                      <a:pPr algn="ctr">
+                        <a:defRPr sz="1200"/>
                       </a:pPr>
                       <a:r>
-                        <a:rPr lang="en-US" sz="1100" dirty="0">
-                          <a:solidFill>
-                            <a:srgbClr val="000000"/>
-                          </a:solidFill>
-                          <a:latin typeface="Calibri" pitchFamily="34" charset="0"/>
-                          <a:ea typeface="Calibri" pitchFamily="34" charset="-122"/>
-                          <a:cs typeface="Calibri" pitchFamily="34" charset="-120"/>
-                        </a:rPr>
-                        <a:t>10</a:t>
+                        <a:t>6</a:t>
                       </a:r>
-                      <a:endParaRPr lang="en-US" sz="1100" dirty="0">
-                        <a:latin typeface="Calibri" charset="0"/>
-                        <a:ea typeface="Calibri" charset="0"/>
-                        <a:cs typeface="Calibri" charset="0"/>
-                      </a:endParaRPr>
                     </a:p>
                   </a:txBody>
-                  <a:tcPr>
-                    <a:lnL w="6350" cap="flat" cmpd="sng" algn="ctr">
-                      <a:solidFill>
-                        <a:srgbClr val="CBD5E1"/>
-                      </a:solidFill>
-                      <a:prstDash val="solid"/>
-                      <a:round/>
-                      <a:headEnd type="none" w="med" len="med"/>
-                      <a:tailEnd type="none" w="med" len="med"/>
-                    </a:lnL>
-                    <a:lnR w="6350" cap="flat" cmpd="sng" algn="ctr">
-                      <a:solidFill>
-                        <a:srgbClr val="CBD5E1"/>
-                      </a:solidFill>
-                      <a:prstDash val="solid"/>
-                      <a:round/>
-                      <a:headEnd type="none" w="med" len="med"/>
-                      <a:tailEnd type="none" w="med" len="med"/>
-                    </a:lnR>
-                    <a:lnT w="6350" cap="flat" cmpd="sng" algn="ctr">
-                      <a:solidFill>
-                        <a:srgbClr val="CBD5E1"/>
-                      </a:solidFill>
-                      <a:prstDash val="solid"/>
-                      <a:round/>
-                      <a:headEnd type="none" w="med" len="med"/>
-                      <a:tailEnd type="none" w="med" len="med"/>
-                    </a:lnT>
-                    <a:lnB w="6350" cap="flat" cmpd="sng" algn="ctr">
-                      <a:solidFill>
-                        <a:srgbClr val="CBD5E1"/>
-                      </a:solidFill>
-                      <a:prstDash val="solid"/>
-                      <a:round/>
-                      <a:headEnd type="none" w="med" len="med"/>
-                      <a:tailEnd type="none" w="med" len="med"/>
-                    </a:lnB>
-                  </a:tcPr>
+                  <a:tcPr/>
                 </a:tc>
                 <a:tc>
                   <a:txBody>
                     <a:bodyPr/>
                     <a:lstStyle/>
                     <a:p>
-                      <a:pPr marL="0" indent="0" algn="ctr">
-                        <a:buNone/>
+                      <a:pPr algn="ctr">
+                        <a:defRPr sz="1200"/>
                       </a:pPr>
                       <a:r>
-                        <a:rPr lang="en-US" sz="1100" dirty="0">
-                          <a:solidFill>
-                            <a:srgbClr val="000000"/>
-                          </a:solidFill>
-                          <a:latin typeface="Calibri" pitchFamily="34" charset="0"/>
-                          <a:ea typeface="Calibri" pitchFamily="34" charset="-122"/>
-                          <a:cs typeface="Calibri" pitchFamily="34" charset="-120"/>
-                        </a:rPr>
                         <a:t>6</a:t>
                       </a:r>
-                      <a:endParaRPr lang="en-US" sz="1100" dirty="0">
-                        <a:latin typeface="Calibri" charset="0"/>
-                        <a:ea typeface="Calibri" charset="0"/>
-                        <a:cs typeface="Calibri" charset="0"/>
-                      </a:endParaRPr>
                     </a:p>
                   </a:txBody>
-                  <a:tcPr>
-                    <a:lnL w="6350" cap="flat" cmpd="sng" algn="ctr">
-                      <a:solidFill>
-                        <a:srgbClr val="CBD5E1"/>
-                      </a:solidFill>
-                      <a:prstDash val="solid"/>
-                      <a:round/>
-                      <a:headEnd type="none" w="med" len="med"/>
-                      <a:tailEnd type="none" w="med" len="med"/>
-                    </a:lnL>
-                    <a:lnR w="6350" cap="flat" cmpd="sng" algn="ctr">
-                      <a:solidFill>
-                        <a:srgbClr val="CBD5E1"/>
-                      </a:solidFill>
-                      <a:prstDash val="solid"/>
-                      <a:round/>
-                      <a:headEnd type="none" w="med" len="med"/>
-                      <a:tailEnd type="none" w="med" len="med"/>
-                    </a:lnR>
-                    <a:lnT w="6350" cap="flat" cmpd="sng" algn="ctr">
-                      <a:solidFill>
-                        <a:srgbClr val="CBD5E1"/>
-                      </a:solidFill>
-                      <a:prstDash val="solid"/>
-                      <a:round/>
-                      <a:headEnd type="none" w="med" len="med"/>
-                      <a:tailEnd type="none" w="med" len="med"/>
-                    </a:lnT>
-                    <a:lnB w="6350" cap="flat" cmpd="sng" algn="ctr">
-                      <a:solidFill>
-                        <a:srgbClr val="CBD5E1"/>
-                      </a:solidFill>
-                      <a:prstDash val="solid"/>
-                      <a:round/>
-                      <a:headEnd type="none" w="med" len="med"/>
-                      <a:tailEnd type="none" w="med" len="med"/>
-                    </a:lnB>
-                  </a:tcPr>
+                  <a:tcPr/>
                 </a:tc>
                 <a:extLst>
                   <a:ext uri="{0D108BD9-81ED-4DB2-BD59-A6C34878D82A}">
@@ -29192,309 +27013,81 @@
                   </a:ext>
                 </a:extLst>
               </a:tr>
-              <a:tr h="320040">
+              <a:tr h="226970">
                 <a:tc>
                   <a:txBody>
                     <a:bodyPr/>
                     <a:lstStyle/>
                     <a:p>
-                      <a:pPr marL="0" indent="0" algn="ctr">
-                        <a:buNone/>
+                      <a:pPr algn="ctr">
+                        <a:defRPr sz="1200"/>
                       </a:pPr>
                       <a:r>
-                        <a:rPr lang="en-US" sz="1100" b="1" dirty="0">
-                          <a:solidFill>
-                            <a:srgbClr val="000000"/>
-                          </a:solidFill>
-                          <a:latin typeface="Calibri" pitchFamily="34" charset="0"/>
-                          <a:ea typeface="Calibri" pitchFamily="34" charset="-122"/>
-                          <a:cs typeface="Calibri" pitchFamily="34" charset="-120"/>
-                        </a:rPr>
-                        <a:t>TOTAL</a:t>
+                        <a:t>pa_6_rev</a:t>
                       </a:r>
-                      <a:endParaRPr lang="en-US" sz="1100" dirty="0">
-                        <a:latin typeface="Calibri" charset="0"/>
-                        <a:ea typeface="Calibri" charset="0"/>
-                        <a:cs typeface="Calibri" charset="0"/>
-                      </a:endParaRPr>
                     </a:p>
                   </a:txBody>
-                  <a:tcPr>
-                    <a:lnL w="6350" cap="flat" cmpd="sng" algn="ctr">
-                      <a:solidFill>
-                        <a:srgbClr val="CBD5E1"/>
-                      </a:solidFill>
-                      <a:prstDash val="solid"/>
-                      <a:round/>
-                      <a:headEnd type="none" w="med" len="med"/>
-                      <a:tailEnd type="none" w="med" len="med"/>
-                    </a:lnL>
-                    <a:lnR w="6350" cap="flat" cmpd="sng" algn="ctr">
-                      <a:solidFill>
-                        <a:srgbClr val="CBD5E1"/>
-                      </a:solidFill>
-                      <a:prstDash val="solid"/>
-                      <a:round/>
-                      <a:headEnd type="none" w="med" len="med"/>
-                      <a:tailEnd type="none" w="med" len="med"/>
-                    </a:lnR>
-                    <a:lnT w="6350" cap="flat" cmpd="sng" algn="ctr">
-                      <a:solidFill>
-                        <a:srgbClr val="CBD5E1"/>
-                      </a:solidFill>
-                      <a:prstDash val="solid"/>
-                      <a:round/>
-                      <a:headEnd type="none" w="med" len="med"/>
-                      <a:tailEnd type="none" w="med" len="med"/>
-                    </a:lnT>
-                    <a:lnB w="6350" cap="flat" cmpd="sng" algn="ctr">
-                      <a:solidFill>
-                        <a:srgbClr val="CBD5E1"/>
-                      </a:solidFill>
-                      <a:prstDash val="solid"/>
-                      <a:round/>
-                      <a:headEnd type="none" w="med" len="med"/>
-                      <a:tailEnd type="none" w="med" len="med"/>
-                    </a:lnB>
-                  </a:tcPr>
+                  <a:tcPr/>
                 </a:tc>
                 <a:tc>
                   <a:txBody>
                     <a:bodyPr/>
                     <a:lstStyle/>
                     <a:p>
-                      <a:pPr marL="0" indent="0" algn="ctr">
-                        <a:buNone/>
+                      <a:pPr algn="ctr">
+                        <a:defRPr sz="1200"/>
                       </a:pPr>
-                      <a:endParaRPr lang="en-US" sz="1100" dirty="0">
-                        <a:latin typeface="Calibri" charset="0"/>
-                        <a:ea typeface="Calibri" charset="0"/>
-                        <a:cs typeface="Calibri" charset="0"/>
-                      </a:endParaRPr>
+                      <a:r>
+                        <a:t>-E5</a:t>
+                      </a:r>
                     </a:p>
                   </a:txBody>
-                  <a:tcPr>
-                    <a:lnL w="6350" cap="flat" cmpd="sng" algn="ctr">
-                      <a:solidFill>
-                        <a:srgbClr val="CBD5E1"/>
-                      </a:solidFill>
-                      <a:prstDash val="solid"/>
-                      <a:round/>
-                      <a:headEnd type="none" w="med" len="med"/>
-                      <a:tailEnd type="none" w="med" len="med"/>
-                    </a:lnL>
-                    <a:lnR w="6350" cap="flat" cmpd="sng" algn="ctr">
-                      <a:solidFill>
-                        <a:srgbClr val="CBD5E1"/>
-                      </a:solidFill>
-                      <a:prstDash val="solid"/>
-                      <a:round/>
-                      <a:headEnd type="none" w="med" len="med"/>
-                      <a:tailEnd type="none" w="med" len="med"/>
-                    </a:lnR>
-                    <a:lnT w="6350" cap="flat" cmpd="sng" algn="ctr">
-                      <a:solidFill>
-                        <a:srgbClr val="CBD5E1"/>
-                      </a:solidFill>
-                      <a:prstDash val="solid"/>
-                      <a:round/>
-                      <a:headEnd type="none" w="med" len="med"/>
-                      <a:tailEnd type="none" w="med" len="med"/>
-                    </a:lnT>
-                    <a:lnB w="6350" cap="flat" cmpd="sng" algn="ctr">
-                      <a:solidFill>
-                        <a:srgbClr val="CBD5E1"/>
-                      </a:solidFill>
-                      <a:prstDash val="solid"/>
-                      <a:round/>
-                      <a:headEnd type="none" w="med" len="med"/>
-                      <a:tailEnd type="none" w="med" len="med"/>
-                    </a:lnB>
-                  </a:tcPr>
+                  <a:tcPr/>
                 </a:tc>
                 <a:tc>
                   <a:txBody>
                     <a:bodyPr/>
                     <a:lstStyle/>
                     <a:p>
-                      <a:pPr marL="0" indent="0" algn="ctr">
-                        <a:buNone/>
+                      <a:pPr algn="ctr">
+                        <a:defRPr sz="1200"/>
                       </a:pPr>
-                      <a:endParaRPr lang="en-US" sz="1100" dirty="0">
-                        <a:latin typeface="Calibri" charset="0"/>
-                        <a:ea typeface="Calibri" charset="0"/>
-                        <a:cs typeface="Calibri" charset="0"/>
-                      </a:endParaRPr>
+                      <a:r>
+                        <a:t>30</a:t>
+                      </a:r>
                     </a:p>
                   </a:txBody>
-                  <a:tcPr>
-                    <a:lnL w="6350" cap="flat" cmpd="sng" algn="ctr">
-                      <a:solidFill>
-                        <a:srgbClr val="CBD5E1"/>
-                      </a:solidFill>
-                      <a:prstDash val="solid"/>
-                      <a:round/>
-                      <a:headEnd type="none" w="med" len="med"/>
-                      <a:tailEnd type="none" w="med" len="med"/>
-                    </a:lnL>
-                    <a:lnR w="6350" cap="flat" cmpd="sng" algn="ctr">
-                      <a:solidFill>
-                        <a:srgbClr val="CBD5E1"/>
-                      </a:solidFill>
-                      <a:prstDash val="solid"/>
-                      <a:round/>
-                      <a:headEnd type="none" w="med" len="med"/>
-                      <a:tailEnd type="none" w="med" len="med"/>
-                    </a:lnR>
-                    <a:lnT w="6350" cap="flat" cmpd="sng" algn="ctr">
-                      <a:solidFill>
-                        <a:srgbClr val="CBD5E1"/>
-                      </a:solidFill>
-                      <a:prstDash val="solid"/>
-                      <a:round/>
-                      <a:headEnd type="none" w="med" len="med"/>
-                      <a:tailEnd type="none" w="med" len="med"/>
-                    </a:lnT>
-                    <a:lnB w="6350" cap="flat" cmpd="sng" algn="ctr">
-                      <a:solidFill>
-                        <a:srgbClr val="CBD5E1"/>
-                      </a:solidFill>
-                      <a:prstDash val="solid"/>
-                      <a:round/>
-                      <a:headEnd type="none" w="med" len="med"/>
-                      <a:tailEnd type="none" w="med" len="med"/>
-                    </a:lnB>
-                  </a:tcPr>
+                  <a:tcPr/>
                 </a:tc>
                 <a:tc>
                   <a:txBody>
                     <a:bodyPr/>
                     <a:lstStyle/>
                     <a:p>
-                      <a:pPr marL="0" indent="0" algn="ctr">
-                        <a:buNone/>
+                      <a:pPr algn="ctr">
+                        <a:defRPr sz="1200"/>
                       </a:pPr>
                       <a:r>
-                        <a:rPr lang="en-US" sz="1100" b="1" dirty="0">
-                          <a:solidFill>
-                            <a:srgbClr val="000000"/>
-                          </a:solidFill>
-                          <a:latin typeface="Calibri" pitchFamily="34" charset="0"/>
-                          <a:ea typeface="Calibri" pitchFamily="34" charset="-122"/>
-                          <a:cs typeface="Calibri" pitchFamily="34" charset="-120"/>
-                        </a:rPr>
-                        <a:t>62</a:t>
+                        <a:t>6</a:t>
                       </a:r>
-                      <a:endParaRPr lang="en-US" sz="1100" dirty="0">
-                        <a:latin typeface="Calibri" charset="0"/>
-                        <a:ea typeface="Calibri" charset="0"/>
-                        <a:cs typeface="Calibri" charset="0"/>
-                      </a:endParaRPr>
                     </a:p>
                   </a:txBody>
-                  <a:tcPr>
-                    <a:lnL w="6350" cap="flat" cmpd="sng" algn="ctr">
-                      <a:solidFill>
-                        <a:srgbClr val="CBD5E1"/>
-                      </a:solidFill>
-                      <a:prstDash val="solid"/>
-                      <a:round/>
-                      <a:headEnd type="none" w="med" len="med"/>
-                      <a:tailEnd type="none" w="med" len="med"/>
-                    </a:lnL>
-                    <a:lnR w="6350" cap="flat" cmpd="sng" algn="ctr">
-                      <a:solidFill>
-                        <a:srgbClr val="CBD5E1"/>
-                      </a:solidFill>
-                      <a:prstDash val="solid"/>
-                      <a:round/>
-                      <a:headEnd type="none" w="med" len="med"/>
-                      <a:tailEnd type="none" w="med" len="med"/>
-                    </a:lnR>
-                    <a:lnT w="6350" cap="flat" cmpd="sng" algn="ctr">
-                      <a:solidFill>
-                        <a:srgbClr val="CBD5E1"/>
-                      </a:solidFill>
-                      <a:prstDash val="solid"/>
-                      <a:round/>
-                      <a:headEnd type="none" w="med" len="med"/>
-                      <a:tailEnd type="none" w="med" len="med"/>
-                    </a:lnT>
-                    <a:lnB w="6350" cap="flat" cmpd="sng" algn="ctr">
-                      <a:solidFill>
-                        <a:srgbClr val="CBD5E1"/>
-                      </a:solidFill>
-                      <a:prstDash val="solid"/>
-                      <a:round/>
-                      <a:headEnd type="none" w="med" len="med"/>
-                      <a:tailEnd type="none" w="med" len="med"/>
-                    </a:lnB>
-                  </a:tcPr>
+                  <a:tcPr/>
                 </a:tc>
                 <a:tc>
                   <a:txBody>
                     <a:bodyPr/>
                     <a:lstStyle/>
                     <a:p>
-                      <a:pPr marL="0" indent="0" algn="ctr">
-                        <a:buNone/>
+                      <a:pPr algn="ctr">
+                        <a:defRPr sz="1200"/>
                       </a:pPr>
                       <a:r>
-                        <a:rPr lang="en-US" sz="1100" b="1" dirty="0">
-                          <a:solidFill>
-                            <a:srgbClr val="000000"/>
-                          </a:solidFill>
-                          <a:latin typeface="Calibri" pitchFamily="34" charset="0"/>
-                          <a:ea typeface="Calibri" pitchFamily="34" charset="-122"/>
-                          <a:cs typeface="Calibri" pitchFamily="34" charset="-120"/>
-                        </a:rPr>
-                        <a:t>49</a:t>
+                        <a:t>3</a:t>
                       </a:r>
-                      <a:endParaRPr lang="en-US" sz="1100" dirty="0">
-                        <a:latin typeface="Calibri" charset="0"/>
-                        <a:ea typeface="Calibri" charset="0"/>
-                        <a:cs typeface="Calibri" charset="0"/>
-                      </a:endParaRPr>
                     </a:p>
                   </a:txBody>
-                  <a:tcPr>
-                    <a:lnL w="6350" cap="flat" cmpd="sng" algn="ctr">
-                      <a:solidFill>
-                        <a:srgbClr val="CBD5E1"/>
-                      </a:solidFill>
-                      <a:prstDash val="solid"/>
-                      <a:round/>
-                      <a:headEnd type="none" w="med" len="med"/>
-                      <a:tailEnd type="none" w="med" len="med"/>
-                    </a:lnL>
-                    <a:lnR w="6350" cap="flat" cmpd="sng" algn="ctr">
-                      <a:solidFill>
-                        <a:srgbClr val="CBD5E1"/>
-                      </a:solidFill>
-                      <a:prstDash val="solid"/>
-                      <a:round/>
-                      <a:headEnd type="none" w="med" len="med"/>
-                      <a:tailEnd type="none" w="med" len="med"/>
-                    </a:lnR>
-                    <a:lnT w="6350" cap="flat" cmpd="sng" algn="ctr">
-                      <a:solidFill>
-                        <a:srgbClr val="CBD5E1"/>
-                      </a:solidFill>
-                      <a:prstDash val="solid"/>
-                      <a:round/>
-                      <a:headEnd type="none" w="med" len="med"/>
-                      <a:tailEnd type="none" w="med" len="med"/>
-                    </a:lnT>
-                    <a:lnB w="6350" cap="flat" cmpd="sng" algn="ctr">
-                      <a:solidFill>
-                        <a:srgbClr val="CBD5E1"/>
-                      </a:solidFill>
-                      <a:prstDash val="solid"/>
-                      <a:round/>
-                      <a:headEnd type="none" w="med" len="med"/>
-                      <a:tailEnd type="none" w="med" len="med"/>
-                    </a:lnB>
-                  </a:tcPr>
+                  <a:tcPr/>
                 </a:tc>
                 <a:extLst>
                   <a:ext uri="{0D108BD9-81ED-4DB2-BD59-A6C34878D82A}">
@@ -29502,10 +27095,498 @@
                   </a:ext>
                 </a:extLst>
               </a:tr>
+              <a:tr h="226970">
+                <a:tc>
+                  <a:txBody>
+                    <a:bodyPr/>
+                    <a:lstStyle/>
+                    <a:p>
+                      <a:pPr algn="ctr">
+                        <a:defRPr sz="1200"/>
+                      </a:pPr>
+                      <a:r>
+                        <a:t>pa_7</a:t>
+                      </a:r>
+                    </a:p>
+                  </a:txBody>
+                  <a:tcPr/>
+                </a:tc>
+                <a:tc>
+                  <a:txBody>
+                    <a:bodyPr/>
+                    <a:lstStyle/>
+                    <a:p>
+                      <a:pPr algn="ctr">
+                        <a:defRPr sz="1200"/>
+                      </a:pPr>
+                      <a:r>
+                        <a:t>E6</a:t>
+                      </a:r>
+                    </a:p>
+                  </a:txBody>
+                  <a:tcPr/>
+                </a:tc>
+                <a:tc>
+                  <a:txBody>
+                    <a:bodyPr/>
+                    <a:lstStyle/>
+                    <a:p>
+                      <a:pPr algn="ctr">
+                        <a:defRPr sz="1200"/>
+                      </a:pPr>
+                      <a:r>
+                        <a:t>30</a:t>
+                      </a:r>
+                    </a:p>
+                  </a:txBody>
+                  <a:tcPr/>
+                </a:tc>
+                <a:tc>
+                  <a:txBody>
+                    <a:bodyPr/>
+                    <a:lstStyle/>
+                    <a:p>
+                      <a:pPr algn="ctr">
+                        <a:defRPr sz="1200"/>
+                      </a:pPr>
+                      <a:r>
+                        <a:t>6</a:t>
+                      </a:r>
+                    </a:p>
+                  </a:txBody>
+                  <a:tcPr/>
+                </a:tc>
+                <a:tc>
+                  <a:txBody>
+                    <a:bodyPr/>
+                    <a:lstStyle/>
+                    <a:p>
+                      <a:pPr algn="ctr">
+                        <a:defRPr sz="1200"/>
+                      </a:pPr>
+                      <a:r>
+                        <a:t>6</a:t>
+                      </a:r>
+                    </a:p>
+                  </a:txBody>
+                  <a:tcPr/>
+                </a:tc>
+                <a:extLst>
+                  <a:ext uri="{0D108BD9-81ED-4DB2-BD59-A6C34878D82A}">
+                    <a16:rowId xmlns:a16="http://schemas.microsoft.com/office/drawing/2014/main" val="10007"/>
+                  </a:ext>
+                </a:extLst>
+              </a:tr>
+              <a:tr h="226970">
+                <a:tc>
+                  <a:txBody>
+                    <a:bodyPr/>
+                    <a:lstStyle/>
+                    <a:p>
+                      <a:pPr algn="ctr">
+                        <a:defRPr sz="1200"/>
+                      </a:pPr>
+                      <a:r>
+                        <a:t>pa_7_rev</a:t>
+                      </a:r>
+                    </a:p>
+                  </a:txBody>
+                  <a:tcPr/>
+                </a:tc>
+                <a:tc>
+                  <a:txBody>
+                    <a:bodyPr/>
+                    <a:lstStyle/>
+                    <a:p>
+                      <a:pPr algn="ctr">
+                        <a:defRPr sz="1200"/>
+                      </a:pPr>
+                      <a:r>
+                        <a:t>-E6</a:t>
+                      </a:r>
+                    </a:p>
+                  </a:txBody>
+                  <a:tcPr/>
+                </a:tc>
+                <a:tc>
+                  <a:txBody>
+                    <a:bodyPr/>
+                    <a:lstStyle/>
+                    <a:p>
+                      <a:pPr algn="ctr">
+                        <a:defRPr sz="1200"/>
+                      </a:pPr>
+                      <a:r>
+                        <a:t>30</a:t>
+                      </a:r>
+                    </a:p>
+                  </a:txBody>
+                  <a:tcPr/>
+                </a:tc>
+                <a:tc>
+                  <a:txBody>
+                    <a:bodyPr/>
+                    <a:lstStyle/>
+                    <a:p>
+                      <a:pPr algn="ctr">
+                        <a:defRPr sz="1200"/>
+                      </a:pPr>
+                      <a:r>
+                        <a:t>6</a:t>
+                      </a:r>
+                    </a:p>
+                  </a:txBody>
+                  <a:tcPr/>
+                </a:tc>
+                <a:tc>
+                  <a:txBody>
+                    <a:bodyPr/>
+                    <a:lstStyle/>
+                    <a:p>
+                      <a:pPr algn="ctr">
+                        <a:defRPr sz="1200"/>
+                      </a:pPr>
+                      <a:r>
+                        <a:t>6</a:t>
+                      </a:r>
+                    </a:p>
+                  </a:txBody>
+                  <a:tcPr/>
+                </a:tc>
+                <a:extLst>
+                  <a:ext uri="{0D108BD9-81ED-4DB2-BD59-A6C34878D82A}">
+                    <a16:rowId xmlns:a16="http://schemas.microsoft.com/office/drawing/2014/main" val="10008"/>
+                  </a:ext>
+                </a:extLst>
+              </a:tr>
+              <a:tr h="226970">
+                <a:tc>
+                  <a:txBody>
+                    <a:bodyPr/>
+                    <a:lstStyle/>
+                    <a:p>
+                      <a:pPr algn="ctr">
+                        <a:defRPr sz="1200"/>
+                      </a:pPr>
+                      <a:r>
+                        <a:t>pa_8</a:t>
+                      </a:r>
+                    </a:p>
+                  </a:txBody>
+                  <a:tcPr/>
+                </a:tc>
+                <a:tc>
+                  <a:txBody>
+                    <a:bodyPr/>
+                    <a:lstStyle/>
+                    <a:p>
+                      <a:pPr algn="ctr">
+                        <a:defRPr sz="1200"/>
+                      </a:pPr>
+                      <a:r>
+                        <a:t>E7</a:t>
+                      </a:r>
+                    </a:p>
+                  </a:txBody>
+                  <a:tcPr/>
+                </a:tc>
+                <a:tc>
+                  <a:txBody>
+                    <a:bodyPr/>
+                    <a:lstStyle/>
+                    <a:p>
+                      <a:pPr algn="ctr">
+                        <a:defRPr sz="1200"/>
+                      </a:pPr>
+                      <a:r>
+                        <a:t>25</a:t>
+                      </a:r>
+                    </a:p>
+                  </a:txBody>
+                  <a:tcPr/>
+                </a:tc>
+                <a:tc>
+                  <a:txBody>
+                    <a:bodyPr/>
+                    <a:lstStyle/>
+                    <a:p>
+                      <a:pPr algn="ctr">
+                        <a:defRPr sz="1200"/>
+                      </a:pPr>
+                      <a:r>
+                        <a:t>5</a:t>
+                      </a:r>
+                    </a:p>
+                  </a:txBody>
+                  <a:tcPr/>
+                </a:tc>
+                <a:tc>
+                  <a:txBody>
+                    <a:bodyPr/>
+                    <a:lstStyle/>
+                    <a:p>
+                      <a:pPr algn="ctr">
+                        <a:defRPr sz="1200"/>
+                      </a:pPr>
+                      <a:r>
+                        <a:t>3</a:t>
+                      </a:r>
+                    </a:p>
+                  </a:txBody>
+                  <a:tcPr/>
+                </a:tc>
+                <a:extLst>
+                  <a:ext uri="{0D108BD9-81ED-4DB2-BD59-A6C34878D82A}">
+                    <a16:rowId xmlns:a16="http://schemas.microsoft.com/office/drawing/2014/main" val="10009"/>
+                  </a:ext>
+                </a:extLst>
+              </a:tr>
+              <a:tr h="226970">
+                <a:tc>
+                  <a:txBody>
+                    <a:bodyPr/>
+                    <a:lstStyle/>
+                    <a:p>
+                      <a:pPr algn="ctr">
+                        <a:defRPr sz="1200"/>
+                      </a:pPr>
+                      <a:r>
+                        <a:t>pa_8_rev</a:t>
+                      </a:r>
+                    </a:p>
+                  </a:txBody>
+                  <a:tcPr/>
+                </a:tc>
+                <a:tc>
+                  <a:txBody>
+                    <a:bodyPr/>
+                    <a:lstStyle/>
+                    <a:p>
+                      <a:pPr algn="ctr">
+                        <a:defRPr sz="1200"/>
+                      </a:pPr>
+                      <a:r>
+                        <a:t>-E7</a:t>
+                      </a:r>
+                    </a:p>
+                  </a:txBody>
+                  <a:tcPr/>
+                </a:tc>
+                <a:tc>
+                  <a:txBody>
+                    <a:bodyPr/>
+                    <a:lstStyle/>
+                    <a:p>
+                      <a:pPr algn="ctr">
+                        <a:defRPr sz="1200"/>
+                      </a:pPr>
+                      <a:r>
+                        <a:t>50</a:t>
+                      </a:r>
+                    </a:p>
+                  </a:txBody>
+                  <a:tcPr/>
+                </a:tc>
+                <a:tc>
+                  <a:txBody>
+                    <a:bodyPr/>
+                    <a:lstStyle/>
+                    <a:p>
+                      <a:pPr algn="ctr">
+                        <a:defRPr sz="1200"/>
+                      </a:pPr>
+                      <a:r>
+                        <a:t>10</a:t>
+                      </a:r>
+                    </a:p>
+                  </a:txBody>
+                  <a:tcPr/>
+                </a:tc>
+                <a:tc>
+                  <a:txBody>
+                    <a:bodyPr/>
+                    <a:lstStyle/>
+                    <a:p>
+                      <a:pPr algn="ctr">
+                        <a:defRPr sz="1200"/>
+                      </a:pPr>
+                      <a:r>
+                        <a:t>6</a:t>
+                      </a:r>
+                    </a:p>
+                  </a:txBody>
+                  <a:tcPr/>
+                </a:tc>
+                <a:extLst>
+                  <a:ext uri="{0D108BD9-81ED-4DB2-BD59-A6C34878D82A}">
+                    <a16:rowId xmlns:a16="http://schemas.microsoft.com/office/drawing/2014/main" val="10010"/>
+                  </a:ext>
+                </a:extLst>
+              </a:tr>
+              <a:tr h="226970">
+                <a:tc>
+                  <a:txBody>
+                    <a:bodyPr/>
+                    <a:lstStyle/>
+                    <a:p>
+                      <a:pPr algn="ctr">
+                        <a:defRPr sz="1200" b="1"/>
+                      </a:pPr>
+                      <a:r>
+                        <a:t>Total</a:t>
+                      </a:r>
+                    </a:p>
+                  </a:txBody>
+                  <a:tcPr/>
+                </a:tc>
+                <a:tc>
+                  <a:txBody>
+                    <a:bodyPr/>
+                    <a:lstStyle/>
+                    <a:p>
+                      <a:pPr algn="ctr">
+                        <a:defRPr sz="1200" b="1"/>
+                      </a:pPr>
+                      <a:r>
+                        <a:rPr dirty="0"/>
+                        <a:t>–</a:t>
+                      </a:r>
+                    </a:p>
+                  </a:txBody>
+                  <a:tcPr/>
+                </a:tc>
+                <a:tc>
+                  <a:txBody>
+                    <a:bodyPr/>
+                    <a:lstStyle/>
+                    <a:p>
+                      <a:pPr algn="ctr">
+                        <a:defRPr sz="1200" b="1"/>
+                      </a:pPr>
+                      <a:r>
+                        <a:rPr dirty="0"/>
+                        <a:t>–</a:t>
+                      </a:r>
+                    </a:p>
+                  </a:txBody>
+                  <a:tcPr/>
+                </a:tc>
+                <a:tc>
+                  <a:txBody>
+                    <a:bodyPr/>
+                    <a:lstStyle/>
+                    <a:p>
+                      <a:pPr algn="ctr">
+                        <a:defRPr sz="1200" b="1"/>
+                      </a:pPr>
+                      <a:r>
+                        <a:t>62</a:t>
+                      </a:r>
+                    </a:p>
+                  </a:txBody>
+                  <a:tcPr/>
+                </a:tc>
+                <a:tc>
+                  <a:txBody>
+                    <a:bodyPr/>
+                    <a:lstStyle/>
+                    <a:p>
+                      <a:pPr algn="ctr">
+                        <a:defRPr sz="1200" b="1"/>
+                      </a:pPr>
+                      <a:r>
+                        <a:rPr dirty="0"/>
+                        <a:t>49</a:t>
+                      </a:r>
+                    </a:p>
+                  </a:txBody>
+                  <a:tcPr/>
+                </a:tc>
+                <a:extLst>
+                  <a:ext uri="{0D108BD9-81ED-4DB2-BD59-A6C34878D82A}">
+                    <a16:rowId xmlns:a16="http://schemas.microsoft.com/office/drawing/2014/main" val="10011"/>
+                  </a:ext>
+                </a:extLst>
+              </a:tr>
             </a:tbl>
           </a:graphicData>
         </a:graphic>
       </p:graphicFrame>
+      <p:pic>
+        <p:nvPicPr>
+          <p:cNvPr id="35" name="Picture 34">
+            <a:extLst>
+              <a:ext uri="{FF2B5EF4-FFF2-40B4-BE49-F238E27FC236}">
+                <a16:creationId xmlns:a16="http://schemas.microsoft.com/office/drawing/2014/main" id="{5B2B8E6E-A2F0-4855-2C86-CCE50754967B}"/>
+              </a:ext>
+            </a:extLst>
+          </p:cNvPr>
+          <p:cNvPicPr>
+            <a:picLocks noChangeAspect="1"/>
+          </p:cNvPicPr>
+          <p:nvPr/>
+        </p:nvPicPr>
+        <p:blipFill>
+          <a:blip r:embed="rId3"/>
+          <a:stretch>
+            <a:fillRect/>
+          </a:stretch>
+        </p:blipFill>
+        <p:spPr>
+          <a:xfrm>
+            <a:off x="402715" y="1537855"/>
+            <a:ext cx="3753649" cy="3261706"/>
+          </a:xfrm>
+          <a:prstGeom prst="rect">
+            <a:avLst/>
+          </a:prstGeom>
+        </p:spPr>
+      </p:pic>
+      <p:sp>
+        <p:nvSpPr>
+          <p:cNvPr id="36" name="Text 26">
+            <a:extLst>
+              <a:ext uri="{FF2B5EF4-FFF2-40B4-BE49-F238E27FC236}">
+                <a16:creationId xmlns:a16="http://schemas.microsoft.com/office/drawing/2014/main" id="{E6BEC7DC-C1F2-DBC7-B13C-66F843815E23}"/>
+              </a:ext>
+            </a:extLst>
+          </p:cNvPr>
+          <p:cNvSpPr/>
+          <p:nvPr/>
+        </p:nvSpPr>
+        <p:spPr>
+          <a:xfrm>
+            <a:off x="372268" y="1060564"/>
+            <a:ext cx="4389120" cy="292608"/>
+          </a:xfrm>
+          <a:prstGeom prst="rect">
+            <a:avLst/>
+          </a:prstGeom>
+          <a:noFill/>
+          <a:ln/>
+        </p:spPr>
+        <p:txBody>
+          <a:bodyPr wrap="square" lIns="0" tIns="0" rIns="0" bIns="0" rtlCol="0" anchor="ctr"/>
+          <a:lstStyle/>
+          <a:p>
+            <a:pPr marL="0" indent="0">
+              <a:buNone/>
+            </a:pPr>
+            <a:r>
+              <a:rPr lang="en-US" sz="1300" b="1" dirty="0">
+                <a:solidFill>
+                  <a:srgbClr val="1B3A6B"/>
+                </a:solidFill>
+                <a:latin typeface="Calibri" pitchFamily="34" charset="0"/>
+                <a:ea typeface="Calibri" pitchFamily="34" charset="-122"/>
+                <a:cs typeface="Calibri" pitchFamily="34" charset="-120"/>
+              </a:rPr>
+              <a:t>Charging Station Implementation in SUMO</a:t>
+            </a:r>
+            <a:endParaRPr lang="en-US" sz="1300" dirty="0"/>
+          </a:p>
+        </p:txBody>
+      </p:sp>
     </p:spTree>
   </p:cSld>
   <p:clrMapOvr>

</xml_diff>

<commit_message>
added thesis defense presentation and review documentation files
</commit_message>
<xml_diff>
--- a/Thesis-Defense/defense/200112_Defense_Presentation.pptx
+++ b/Thesis-Defense/defense/200112_Defense_Presentation.pptx
@@ -29052,7 +29052,7 @@
         </p:nvSpPr>
         <p:spPr>
           <a:xfrm>
-            <a:off x="5586984" y="1115568"/>
+            <a:off x="5596509" y="1115568"/>
             <a:ext cx="1920240" cy="1143000"/>
           </a:xfrm>
           <a:prstGeom prst="rect">
@@ -29187,7 +29187,7 @@
         </p:nvSpPr>
         <p:spPr>
           <a:xfrm>
-            <a:off x="7342632" y="1115568"/>
+            <a:off x="7352157" y="1115568"/>
             <a:ext cx="1481328" cy="1143000"/>
           </a:xfrm>
           <a:prstGeom prst="rect">
@@ -29219,8 +29219,8 @@
         </p:nvSpPr>
         <p:spPr>
           <a:xfrm>
-            <a:off x="7342632" y="1115568"/>
-            <a:ext cx="1453896" cy="201168"/>
+            <a:off x="7352157" y="1115568"/>
+            <a:ext cx="1481328" cy="201168"/>
           </a:xfrm>
           <a:prstGeom prst="rect">
             <a:avLst/>

</xml_diff>